<commit_message>
docs(pitch): slide 'why this design' + slide 'learn more' (whitepaper, repo, avidost.fr)
Co-Authored-By: Claude Sonnet 5.5 <noreply@anthropic.com>
Claude-Session: https://claude.ai/code/session_01ESQGsx4qUhPLf1kD2HA1F1
</commit_message>
<xml_diff>
--- a/pitch/invarian-pitch.pptx
+++ b/pitch/invarian-pitch.pptx
@@ -17,9 +17,11 @@
     <p:sldId id="265" r:id="rId11"/>
     <p:sldId id="266" r:id="rId12"/>
     <p:sldId id="267" r:id="rId13"/>
+    <p:sldId id="268" r:id="rId14"/>
+    <p:sldId id="269" r:id="rId15"/>
   </p:sldIdLst>
   <p:notesMasterIdLst>
-    <p:notesMasterId r:id="rId14"/>
+    <p:notesMasterId r:id="rId16"/>
   </p:notesMasterIdLst>
   <p:sldSz cx="9144000" cy="5143500"/>
   <p:notesSz cx="5143500" cy="9144000"/>
@@ -118,56 +120,58 @@
   <p:extLst>
     <p:ext uri="{521415D9-36F7-43E2-AB2F-B90AF26B5E84}">
       <p14:sectionLst xmlns:p14="http://schemas.microsoft.com/office/powerpoint/2010/main">
-        <p14:section name="Opening" id="{f9947580-5387-153a-bd6e-5f07881fee3d}">
+        <p14:section name="Opening" id="{43c32f29-e6ef-a632-b738-b30ecab5f96c}">
           <p14:sldIdLst>
             <p14:sldId id="256"/>
           </p14:sldIdLst>
         </p14:section>
-        <p14:section name="Problem" id="{f74a61fc-d14e-b420-58ca-55678d35f7d3}">
+        <p14:section name="Problem" id="{8b025d55-e578-3b5d-da96-dbe2d20fb1ac}">
           <p14:sldIdLst>
             <p14:sldId id="257"/>
           </p14:sldIdLst>
         </p14:section>
-        <p14:section name="Why now" id="{52b73050-078e-459a-c12f-6fe0e7221966}">
+        <p14:section name="Why now" id="{6e3ae11b-1985-742c-cee0-c12f22c49691}">
           <p14:sldIdLst>
             <p14:sldId id="258"/>
           </p14:sldIdLst>
         </p14:section>
-        <p14:section name="Gap" id="{e437af72-cdb5-8b4a-c80b-e109486aea3c}">
+        <p14:section name="Gap" id="{a984f73a-08f1-9a3d-1125-f03b9b96fc72}">
           <p14:sldIdLst>
             <p14:sldId id="259"/>
           </p14:sldIdLst>
         </p14:section>
-        <p14:section name="Solution" id="{7cf760ac-2994-cf1f-0a85-037d1845c9b1}">
+        <p14:section name="Solution" id="{4d36b990-dfe7-a0a3-9f9c-e8b1f168937c}">
           <p14:sldIdLst>
             <p14:sldId id="260"/>
             <p14:sldId id="261"/>
-          </p14:sldIdLst>
-        </p14:section>
-        <p14:section name="Evidence" id="{d3e37a50-e3ec-ebf2-fbe6-d0631427b55f}">
-          <p14:sldIdLst>
             <p14:sldId id="262"/>
           </p14:sldIdLst>
         </p14:section>
-        <p14:section name="Compliance" id="{558c88c6-26e0-906f-de4e-942458d75c0b}">
+        <p14:section name="Evidence" id="{ad13f005-3cd9-2ade-af16-acbdc4da7e9e}">
           <p14:sldIdLst>
             <p14:sldId id="263"/>
           </p14:sldIdLst>
         </p14:section>
-        <p14:section name="Product" id="{2c8a396d-cafa-2f08-0248-c72b970114ab}">
+        <p14:section name="Compliance" id="{be0b4e19-c5df-c786-a704-2d9bad72d9df}">
           <p14:sldIdLst>
             <p14:sldId id="264"/>
           </p14:sldIdLst>
         </p14:section>
-        <p14:section name="Business" id="{c0750d71-ad72-d070-d07b-bc7e64de562b}">
+        <p14:section name="Product" id="{14ac5b5b-93f2-06c5-e97e-45f99299dbb7}">
           <p14:sldIdLst>
             <p14:sldId id="265"/>
           </p14:sldIdLst>
         </p14:section>
-        <p14:section name="Next" id="{9f28d3f7-bb97-58a1-291f-f5bf1295527c}">
+        <p14:section name="Business" id="{16a44c23-7672-000f-81da-7e77fa441c21}">
           <p14:sldIdLst>
             <p14:sldId id="266"/>
+          </p14:sldIdLst>
+        </p14:section>
+        <p14:section name="Next" id="{19d823db-995c-1c13-3838-a7c2723c00fe}">
+          <p14:sldIdLst>
             <p14:sldId id="267"/>
+            <p14:sldId id="268"/>
+            <p14:sldId id="269"/>
           </p14:sldIdLst>
         </p14:section>
       </p14:sectionLst>
@@ -662,7 +666,7 @@
           <a:p>
             <a:r>
               <a:rPr lang="en-US" dirty="0"/>
-              <a:t>Target: sensitive companies and those subject to, or preparing for, EU AI Act obligations. First pilots under way with critical-infrastructure operators (OIV). No pricing or market figures are shown because none are measured yet.</a:t>
+              <a:t>Scale 2 is the next deployment: first cloud pilot with measured friction budget (added tier-1 latency under 5 ms, human arbitration under 10 percent of actions).</a:t>
             </a:r>
             <a:endParaRPr lang="en-US" dirty="0"/>
           </a:p>
@@ -750,7 +754,7 @@
           <a:p>
             <a:r>
               <a:rPr lang="en-US" dirty="0"/>
-              <a:t>Add the raise amount and runway here if desired. State of implementation as of 4 October 2026 (whitepaper section 7).</a:t>
+              <a:t>Target: sensitive companies and those subject to, or preparing for, EU AI Act obligations. First pilots under way with critical-infrastructure operators (OIV). No pricing or market figures are shown because none are measured yet.</a:t>
             </a:r>
             <a:endParaRPr lang="en-US" dirty="0"/>
           </a:p>
@@ -838,7 +842,7 @@
           <a:p>
             <a:r>
               <a:rPr lang="en-US" dirty="0"/>
-              <a:t/>
+              <a:t>Add the raise amount and runway here if desired. State of implementation as of 4 October 2026 (whitepaper section 7).</a:t>
             </a:r>
             <a:endParaRPr lang="en-US" dirty="0"/>
           </a:p>
@@ -862,6 +866,182 @@
             <a:fld id="{F7021451-1387-4CA6-816F-3879F97B5CBC}" type="slidenum">
               <a:rPr lang="en-US"/>
               <a:t>12</a:t>
+            </a:fld>
+            <a:endParaRPr lang="en-US"/>
+          </a:p>
+        </p:txBody>
+      </p:sp>
+    </p:spTree>
+    <p:extLst>
+      <p:ext uri="{BB962C8B-B14F-4D97-AF65-F5344CB8AC3E}">
+        <p14:creationId xmlns:p14="http://schemas.microsoft.com/office/powerpoint/2010/main" val="1024086991"/>
+      </p:ext>
+    </p:extLst>
+  </p:cSld>
+  <p:clrMapOvr>
+    <a:masterClrMapping/>
+  </p:clrMapOvr>
+</p:notes>
+</file>
+
+<file path=ppt/notesSlides/notesSlide13.xml><?xml version="1.0" encoding="utf-8"?>
+<p:notes xmlns:a="http://schemas.openxmlformats.org/drawingml/2006/main" xmlns:r="http://schemas.openxmlformats.org/officeDocument/2006/relationships" xmlns:p="http://schemas.openxmlformats.org/presentationml/2006/main">
+  <p:cSld>
+    <p:spTree>
+      <p:nvGrpSpPr>
+        <p:cNvPr id="1" name=""/>
+        <p:cNvGrpSpPr/>
+        <p:nvPr/>
+      </p:nvGrpSpPr>
+      <p:grpSpPr>
+        <a:xfrm>
+          <a:off x="0" y="0"/>
+          <a:ext cx="0" cy="0"/>
+          <a:chOff x="0" y="0"/>
+          <a:chExt cx="0" cy="0"/>
+        </a:xfrm>
+      </p:grpSpPr>
+      <p:sp>
+        <p:nvSpPr>
+          <p:cNvPr id="2" name="Slide Image Placeholder 1"/>
+          <p:cNvSpPr>
+            <a:spLocks noGrp="1" noRot="1" noChangeAspect="1"/>
+          </p:cNvSpPr>
+          <p:nvPr>
+            <p:ph type="sldImg"/>
+          </p:nvPr>
+        </p:nvSpPr>
+        <p:spPr/>
+      </p:sp>
+      <p:sp>
+        <p:nvSpPr>
+          <p:cNvPr id="3" name="Notes Placeholder 2"/>
+          <p:cNvSpPr>
+            <a:spLocks noGrp="1"/>
+          </p:cNvSpPr>
+          <p:nvPr>
+            <p:ph type="body" idx="1"/>
+          </p:nvPr>
+        </p:nvSpPr>
+        <p:spPr/>
+        <p:txBody>
+          <a:bodyPr/>
+          <a:lstStyle/>
+          <a:p>
+            <a:r>
+              <a:rPr lang="en-US" dirty="0"/>
+              <a:t>Every figure in this deck comes from the whitepaper or the public repository and can be reproduced from them.</a:t>
+            </a:r>
+            <a:endParaRPr lang="en-US" dirty="0"/>
+          </a:p>
+        </p:txBody>
+      </p:sp>
+      <p:sp>
+        <p:nvSpPr>
+          <p:cNvPr id="4" name="Slide Number Placeholder 3"/>
+          <p:cNvSpPr>
+            <a:spLocks noGrp="1"/>
+          </p:cNvSpPr>
+          <p:nvPr>
+            <p:ph type="sldNum" sz="quarter" idx="10"/>
+          </p:nvPr>
+        </p:nvSpPr>
+        <p:spPr/>
+        <p:txBody>
+          <a:bodyPr/>
+          <a:lstStyle/>
+          <a:p>
+            <a:fld id="{F7021451-1387-4CA6-816F-3879F97B5CBC}" type="slidenum">
+              <a:rPr lang="en-US"/>
+              <a:t>13</a:t>
+            </a:fld>
+            <a:endParaRPr lang="en-US"/>
+          </a:p>
+        </p:txBody>
+      </p:sp>
+    </p:spTree>
+    <p:extLst>
+      <p:ext uri="{BB962C8B-B14F-4D97-AF65-F5344CB8AC3E}">
+        <p14:creationId xmlns:p14="http://schemas.microsoft.com/office/powerpoint/2010/main" val="1024086991"/>
+      </p:ext>
+    </p:extLst>
+  </p:cSld>
+  <p:clrMapOvr>
+    <a:masterClrMapping/>
+  </p:clrMapOvr>
+</p:notes>
+</file>
+
+<file path=ppt/notesSlides/notesSlide14.xml><?xml version="1.0" encoding="utf-8"?>
+<p:notes xmlns:a="http://schemas.openxmlformats.org/drawingml/2006/main" xmlns:r="http://schemas.openxmlformats.org/officeDocument/2006/relationships" xmlns:p="http://schemas.openxmlformats.org/presentationml/2006/main">
+  <p:cSld>
+    <p:spTree>
+      <p:nvGrpSpPr>
+        <p:cNvPr id="1" name=""/>
+        <p:cNvGrpSpPr/>
+        <p:nvPr/>
+      </p:nvGrpSpPr>
+      <p:grpSpPr>
+        <a:xfrm>
+          <a:off x="0" y="0"/>
+          <a:ext cx="0" cy="0"/>
+          <a:chOff x="0" y="0"/>
+          <a:chExt cx="0" cy="0"/>
+        </a:xfrm>
+      </p:grpSpPr>
+      <p:sp>
+        <p:nvSpPr>
+          <p:cNvPr id="2" name="Slide Image Placeholder 1"/>
+          <p:cNvSpPr>
+            <a:spLocks noGrp="1" noRot="1" noChangeAspect="1"/>
+          </p:cNvSpPr>
+          <p:nvPr>
+            <p:ph type="sldImg"/>
+          </p:nvPr>
+        </p:nvSpPr>
+        <p:spPr/>
+      </p:sp>
+      <p:sp>
+        <p:nvSpPr>
+          <p:cNvPr id="3" name="Notes Placeholder 2"/>
+          <p:cNvSpPr>
+            <a:spLocks noGrp="1"/>
+          </p:cNvSpPr>
+          <p:nvPr>
+            <p:ph type="body" idx="1"/>
+          </p:nvPr>
+        </p:nvSpPr>
+        <p:spPr/>
+        <p:txBody>
+          <a:bodyPr/>
+          <a:lstStyle/>
+          <a:p>
+            <a:r>
+              <a:rPr lang="en-US" dirty="0"/>
+              <a:t/>
+            </a:r>
+            <a:endParaRPr lang="en-US" dirty="0"/>
+          </a:p>
+        </p:txBody>
+      </p:sp>
+      <p:sp>
+        <p:nvSpPr>
+          <p:cNvPr id="4" name="Slide Number Placeholder 3"/>
+          <p:cNvSpPr>
+            <a:spLocks noGrp="1"/>
+          </p:cNvSpPr>
+          <p:nvPr>
+            <p:ph type="sldNum" sz="quarter" idx="10"/>
+          </p:nvPr>
+        </p:nvSpPr>
+        <p:spPr/>
+        <p:txBody>
+          <a:bodyPr/>
+          <a:lstStyle/>
+          <a:p>
+            <a:fld id="{F7021451-1387-4CA6-816F-3879F97B5CBC}" type="slidenum">
+              <a:rPr lang="en-US"/>
+              <a:t>14</a:t>
             </a:fld>
             <a:endParaRPr lang="en-US"/>
           </a:p>
@@ -1366,7 +1546,7 @@
           <a:p>
             <a:r>
               <a:rPr lang="en-US" dirty="0"/>
-              <a:t>A static review does not establish the absence of flaws; a dynamic campaign is part of the validation lab. Compliance mappings are mappings, not certifications.</a:t>
+              <a:t>Core argument of the whitepaper. Semantic guardrails act on text, their verdict is probabilistic, and they leave no evidence a third party can verify; TBP acts on the action, deterministically, with verifiable evidence.</a:t>
             </a:r>
             <a:endParaRPr lang="en-US" dirty="0"/>
           </a:p>
@@ -1454,7 +1634,7 @@
           <a:p>
             <a:r>
               <a:rPr lang="en-US" dirty="0"/>
-              <a:t>The regulation prescribes demonstrations, not an architecture. For an agent that acts on systems, these demonstrations can only be made where the action is executed.</a:t>
+              <a:t>A static review does not establish the absence of flaws; a dynamic campaign is part of the validation lab. Compliance mappings are mappings, not certifications.</a:t>
             </a:r>
             <a:endParaRPr lang="en-US" dirty="0"/>
           </a:p>
@@ -1542,7 +1722,7 @@
           <a:p>
             <a:r>
               <a:rPr lang="en-US" dirty="0"/>
-              <a:t>Scale 2 is the next deployment: first cloud pilot with measured friction budget (added tier-1 latency under 5 ms, human arbitration under 10 percent of actions).</a:t>
+              <a:t>The regulation prescribes demonstrations, not an architecture. For an agent that acts on systems, these demonstrations can only be made where the action is executed.</a:t>
             </a:r>
             <a:endParaRPr lang="en-US" dirty="0"/>
           </a:p>
@@ -2426,10 +2606,10 @@
             <a:r>
               <a:rPr lang="en-US" sz="3000" b="1" dirty="0">
                 <a:solidFill>
-                  <a:schemeClr val="bg1"/>
-                </a:solidFill>
-              </a:rPr>
-              <a:t>Open protocol. Commercial product</a:t>
+                  <a:schemeClr val="tx1"/>
+                </a:solidFill>
+              </a:rPr>
+              <a:t>One code base. The scale is a setting</a:t>
             </a:r>
             <a:endParaRPr lang="en-US" sz="3000" dirty="0"/>
           </a:p>
@@ -2437,26 +2617,26 @@
       </p:sp>
       <p:sp>
         <p:nvSpPr>
-          <p:cNvPr id="3" name="Column 0"/>
+          <p:cNvPr id="3" name="Scale Scale 1"/>
           <p:cNvSpPr/>
           <p:nvPr/>
         </p:nvSpPr>
         <p:spPr>
           <a:xfrm>
-            <a:off x="457200" y="1371600"/>
-            <a:ext cx="4023360" cy="2011680"/>
+            <a:off x="457200" y="1234440"/>
+            <a:ext cx="1920240" cy="2103120"/>
           </a:xfrm>
           <a:prstGeom prst="roundRect">
             <a:avLst>
-              <a:gd name="adj" fmla="val 3636"/>
+              <a:gd name="adj" fmla="val 3810"/>
             </a:avLst>
           </a:prstGeom>
           <a:solidFill>
-            <a:schemeClr val="tx2"/>
+            <a:schemeClr val="bg2"/>
           </a:solidFill>
           <a:ln w="6350">
             <a:solidFill>
-              <a:schemeClr val="tx2"/>
+              <a:schemeClr val="bg2"/>
             </a:solidFill>
             <a:prstDash val="solid"/>
           </a:ln>
@@ -2470,8 +2650,8 @@
         </p:nvSpPr>
         <p:spPr>
           <a:xfrm>
-            <a:off x="685800" y="1508760"/>
-            <a:ext cx="3566160" cy="457200"/>
+            <a:off x="594360" y="1371600"/>
+            <a:ext cx="1645920" cy="365760"/>
           </a:xfrm>
           <a:prstGeom prst="rect">
             <a:avLst/>
@@ -2487,14 +2667,14 @@
               <a:buNone/>
             </a:pPr>
             <a:r>
-              <a:rPr lang="en-US" sz="2000" b="1" dirty="0">
-                <a:solidFill>
-                  <a:schemeClr val="accent5"/>
-                </a:solidFill>
-              </a:rPr>
-              <a:t>TBP: open (Apache 2.0)</a:t>
-            </a:r>
-            <a:endParaRPr lang="en-US" sz="2000" dirty="0"/>
+              <a:rPr lang="en-US" sz="1800" b="1" dirty="0">
+                <a:solidFill>
+                  <a:schemeClr val="accent4"/>
+                </a:solidFill>
+              </a:rPr>
+              <a:t>Scale 1</a:t>
+            </a:r>
+            <a:endParaRPr lang="en-US" sz="1800" dirty="0"/>
           </a:p>
         </p:txBody>
       </p:sp>
@@ -2506,8 +2686,8 @@
         </p:nvSpPr>
         <p:spPr>
           <a:xfrm>
-            <a:off x="685800" y="2057400"/>
-            <a:ext cx="3566160" cy="1188720"/>
+            <a:off x="594360" y="1783080"/>
+            <a:ext cx="1645920" cy="1005840"/>
           </a:xfrm>
           <a:prstGeom prst="rect">
             <a:avLst/>
@@ -2523,39 +2703,75 @@
               <a:buNone/>
             </a:pPr>
             <a:r>
-              <a:rPr lang="en-US" sz="1500" dirty="0">
-                <a:solidFill>
-                  <a:schemeClr val="bg1"/>
-                </a:solidFill>
-              </a:rPr>
-              <a:t>Protocol, reference implementation, selftest, deployment guides, compliance mappings. Anyone can read, run and audit it.</a:t>
-            </a:r>
-            <a:endParaRPr lang="en-US" sz="1500" dirty="0"/>
-          </a:p>
-        </p:txBody>
-      </p:sp>
-      <p:sp>
-        <p:nvSpPr>
-          <p:cNvPr id="6" name="Column 1"/>
+              <a:rPr lang="en-US" sz="1400" dirty="0">
+                <a:solidFill>
+                  <a:schemeClr val="tx1"/>
+                </a:solidFill>
+              </a:rPr>
+              <a:t>One machine, one administrator</a:t>
+            </a:r>
+            <a:endParaRPr lang="en-US" sz="1400" dirty="0"/>
+          </a:p>
+        </p:txBody>
+      </p:sp>
+      <p:sp>
+        <p:nvSpPr>
+          <p:cNvPr id="6" name="Text 4"/>
+          <p:cNvSpPr txBox="1"/>
+          <p:nvPr/>
+        </p:nvSpPr>
+        <p:spPr>
+          <a:xfrm>
+            <a:off x="594360" y="2834640"/>
+            <a:ext cx="1645920" cy="365760"/>
+          </a:xfrm>
+          <a:prstGeom prst="rect">
+            <a:avLst/>
+          </a:prstGeom>
+          <a:noFill/>
+          <a:ln/>
+        </p:spPr>
+        <p:txBody>
+          <a:bodyPr wrap="square" lIns="0" tIns="0" rIns="0" bIns="0" rtlCol="0" anchor="ctr"/>
+          <a:lstStyle/>
+          <a:p>
+            <a:pPr indent="0" marL="0">
+              <a:buNone/>
+            </a:pPr>
+            <a:r>
+              <a:rPr lang="en-US" sz="1300" b="1" dirty="0">
+                <a:solidFill>
+                  <a:schemeClr val="tx2"/>
+                </a:solidFill>
+              </a:rPr>
+              <a:t>Quorum: k = 1</a:t>
+            </a:r>
+            <a:endParaRPr lang="en-US" sz="1300" dirty="0"/>
+          </a:p>
+        </p:txBody>
+      </p:sp>
+      <p:sp>
+        <p:nvSpPr>
+          <p:cNvPr id="7" name="Scale Scale 2"/>
           <p:cNvSpPr/>
           <p:nvPr/>
         </p:nvSpPr>
         <p:spPr>
           <a:xfrm>
-            <a:off x="4663440" y="1371600"/>
-            <a:ext cx="4023360" cy="2011680"/>
+            <a:off x="2542032" y="1234440"/>
+            <a:ext cx="1920240" cy="2103120"/>
           </a:xfrm>
           <a:prstGeom prst="roundRect">
             <a:avLst>
-              <a:gd name="adj" fmla="val 3636"/>
+              <a:gd name="adj" fmla="val 3810"/>
             </a:avLst>
           </a:prstGeom>
           <a:solidFill>
-            <a:schemeClr val="tx2"/>
+            <a:schemeClr val="bg2"/>
           </a:solidFill>
           <a:ln w="6350">
             <a:solidFill>
-              <a:schemeClr val="tx2"/>
+              <a:schemeClr val="bg2"/>
             </a:solidFill>
             <a:prstDash val="solid"/>
           </a:ln>
@@ -2563,73 +2779,37 @@
       </p:sp>
       <p:sp>
         <p:nvSpPr>
-          <p:cNvPr id="7" name="Text 5"/>
-          <p:cNvSpPr txBox="1"/>
-          <p:nvPr/>
-        </p:nvSpPr>
-        <p:spPr>
-          <a:xfrm>
-            <a:off x="4892040" y="1508760"/>
-            <a:ext cx="3566160" cy="457200"/>
-          </a:xfrm>
-          <a:prstGeom prst="rect">
-            <a:avLst/>
-          </a:prstGeom>
-          <a:noFill/>
-          <a:ln/>
-        </p:spPr>
-        <p:txBody>
-          <a:bodyPr wrap="square" lIns="0" tIns="0" rIns="0" bIns="0" rtlCol="0" anchor="ctr"/>
-          <a:lstStyle/>
-          <a:p>
-            <a:pPr indent="0" marL="0">
-              <a:buNone/>
-            </a:pPr>
-            <a:r>
-              <a:rPr lang="en-US" sz="2000" b="1" dirty="0">
-                <a:solidFill>
-                  <a:schemeClr val="accent5"/>
-                </a:solidFill>
-              </a:rPr>
-              <a:t>INVARIAN: Avidost's product</a:t>
-            </a:r>
-            <a:endParaRPr lang="en-US" sz="2000" dirty="0"/>
-          </a:p>
-        </p:txBody>
-      </p:sp>
-      <p:sp>
-        <p:nvSpPr>
           <p:cNvPr id="8" name="Text 6"/>
           <p:cNvSpPr txBox="1"/>
           <p:nvPr/>
         </p:nvSpPr>
         <p:spPr>
           <a:xfrm>
-            <a:off x="4892040" y="2057400"/>
-            <a:ext cx="3566160" cy="1188720"/>
-          </a:xfrm>
-          <a:prstGeom prst="rect">
-            <a:avLst/>
-          </a:prstGeom>
-          <a:noFill/>
-          <a:ln/>
-        </p:spPr>
-        <p:txBody>
-          <a:bodyPr wrap="square" lIns="0" tIns="0" rIns="0" bIns="0" rtlCol="0" anchor="t"/>
+            <a:off x="2679192" y="1371600"/>
+            <a:ext cx="1645920" cy="365760"/>
+          </a:xfrm>
+          <a:prstGeom prst="rect">
+            <a:avLst/>
+          </a:prstGeom>
+          <a:noFill/>
+          <a:ln/>
+        </p:spPr>
+        <p:txBody>
+          <a:bodyPr wrap="square" lIns="0" tIns="0" rIns="0" bIns="0" rtlCol="0" anchor="ctr"/>
           <a:lstStyle/>
           <a:p>
             <a:pPr indent="0" marL="0">
               <a:buNone/>
             </a:pPr>
             <a:r>
-              <a:rPr lang="en-US" sz="1500" dirty="0">
-                <a:solidFill>
-                  <a:schemeClr val="bg1"/>
-                </a:solidFill>
-              </a:rPr>
-              <a:t>Built on TBP for organizations that must demonstrate control: sensitive sectors and teams preparing for EU AI Act obligations.</a:t>
-            </a:r>
-            <a:endParaRPr lang="en-US" sz="1500" dirty="0"/>
+              <a:rPr lang="en-US" sz="1800" b="1" dirty="0">
+                <a:solidFill>
+                  <a:schemeClr val="accent1"/>
+                </a:solidFill>
+              </a:rPr>
+              <a:t>Scale 2</a:t>
+            </a:r>
+            <a:endParaRPr lang="en-US" sz="1800" dirty="0"/>
           </a:p>
         </p:txBody>
       </p:sp>
@@ -2641,8 +2821,8 @@
         </p:nvSpPr>
         <p:spPr>
           <a:xfrm>
-            <a:off x="457200" y="3657600"/>
-            <a:ext cx="8229600" cy="822960"/>
+            <a:off x="2679192" y="1783080"/>
+            <a:ext cx="1645920" cy="1005840"/>
           </a:xfrm>
           <a:prstGeom prst="rect">
             <a:avLst/>
@@ -2658,14 +2838,401 @@
               <a:buNone/>
             </a:pPr>
             <a:r>
+              <a:rPr lang="en-US" sz="1400" dirty="0">
+                <a:solidFill>
+                  <a:schemeClr val="tx1"/>
+                </a:solidFill>
+              </a:rPr>
+              <a:t>Small site behind one broker, 802.1X</a:t>
+            </a:r>
+            <a:endParaRPr lang="en-US" sz="1400" dirty="0"/>
+          </a:p>
+        </p:txBody>
+      </p:sp>
+      <p:sp>
+        <p:nvSpPr>
+          <p:cNvPr id="10" name="Text 8"/>
+          <p:cNvSpPr txBox="1"/>
+          <p:nvPr/>
+        </p:nvSpPr>
+        <p:spPr>
+          <a:xfrm>
+            <a:off x="2679192" y="2834640"/>
+            <a:ext cx="1645920" cy="365760"/>
+          </a:xfrm>
+          <a:prstGeom prst="rect">
+            <a:avLst/>
+          </a:prstGeom>
+          <a:noFill/>
+          <a:ln/>
+        </p:spPr>
+        <p:txBody>
+          <a:bodyPr wrap="square" lIns="0" tIns="0" rIns="0" bIns="0" rtlCol="0" anchor="ctr"/>
+          <a:lstStyle/>
+          <a:p>
+            <a:pPr indent="0" marL="0">
+              <a:buNone/>
+            </a:pPr>
+            <a:r>
+              <a:rPr lang="en-US" sz="1300" b="1" dirty="0">
+                <a:solidFill>
+                  <a:schemeClr val="tx2"/>
+                </a:solidFill>
+              </a:rPr>
+              <a:t>Quorum: k = 2 of 3</a:t>
+            </a:r>
+            <a:endParaRPr lang="en-US" sz="1300" dirty="0"/>
+          </a:p>
+        </p:txBody>
+      </p:sp>
+      <p:sp>
+        <p:nvSpPr>
+          <p:cNvPr id="11" name="Scale Scale 3"/>
+          <p:cNvSpPr/>
+          <p:nvPr/>
+        </p:nvSpPr>
+        <p:spPr>
+          <a:xfrm>
+            <a:off x="4626864" y="1234440"/>
+            <a:ext cx="1920240" cy="2103120"/>
+          </a:xfrm>
+          <a:prstGeom prst="roundRect">
+            <a:avLst>
+              <a:gd name="adj" fmla="val 3810"/>
+            </a:avLst>
+          </a:prstGeom>
+          <a:solidFill>
+            <a:schemeClr val="bg2"/>
+          </a:solidFill>
+          <a:ln w="6350">
+            <a:solidFill>
+              <a:schemeClr val="bg2"/>
+            </a:solidFill>
+            <a:prstDash val="solid"/>
+          </a:ln>
+        </p:spPr>
+      </p:sp>
+      <p:sp>
+        <p:nvSpPr>
+          <p:cNvPr id="12" name="Text 10"/>
+          <p:cNvSpPr txBox="1"/>
+          <p:nvPr/>
+        </p:nvSpPr>
+        <p:spPr>
+          <a:xfrm>
+            <a:off x="4764024" y="1371600"/>
+            <a:ext cx="1645920" cy="365760"/>
+          </a:xfrm>
+          <a:prstGeom prst="rect">
+            <a:avLst/>
+          </a:prstGeom>
+          <a:noFill/>
+          <a:ln/>
+        </p:spPr>
+        <p:txBody>
+          <a:bodyPr wrap="square" lIns="0" tIns="0" rIns="0" bIns="0" rtlCol="0" anchor="ctr"/>
+          <a:lstStyle/>
+          <a:p>
+            <a:pPr indent="0" marL="0">
+              <a:buNone/>
+            </a:pPr>
+            <a:r>
+              <a:rPr lang="en-US" sz="1800" b="1" dirty="0">
+                <a:solidFill>
+                  <a:schemeClr val="accent1"/>
+                </a:solidFill>
+              </a:rPr>
+              <a:t>Scale 3</a:t>
+            </a:r>
+            <a:endParaRPr lang="en-US" sz="1800" dirty="0"/>
+          </a:p>
+        </p:txBody>
+      </p:sp>
+      <p:sp>
+        <p:nvSpPr>
+          <p:cNvPr id="13" name="Text 11"/>
+          <p:cNvSpPr txBox="1"/>
+          <p:nvPr/>
+        </p:nvSpPr>
+        <p:spPr>
+          <a:xfrm>
+            <a:off x="4764024" y="1783080"/>
+            <a:ext cx="1645920" cy="1005840"/>
+          </a:xfrm>
+          <a:prstGeom prst="rect">
+            <a:avLst/>
+          </a:prstGeom>
+          <a:noFill/>
+          <a:ln/>
+        </p:spPr>
+        <p:txBody>
+          <a:bodyPr wrap="square" lIns="0" tIns="0" rIns="0" bIns="0" rtlCol="0" anchor="t"/>
+          <a:lstStyle/>
+          <a:p>
+            <a:pPr indent="0" marL="0">
+              <a:buNone/>
+            </a:pPr>
+            <a:r>
+              <a:rPr lang="en-US" sz="1400" dirty="0">
+                <a:solidFill>
+                  <a:schemeClr val="tx1"/>
+                </a:solidFill>
+              </a:rPr>
+              <a:t>Several cells, epoch lease, independent supervisor</a:t>
+            </a:r>
+            <a:endParaRPr lang="en-US" sz="1400" dirty="0"/>
+          </a:p>
+        </p:txBody>
+      </p:sp>
+      <p:sp>
+        <p:nvSpPr>
+          <p:cNvPr id="14" name="Text 12"/>
+          <p:cNvSpPr txBox="1"/>
+          <p:nvPr/>
+        </p:nvSpPr>
+        <p:spPr>
+          <a:xfrm>
+            <a:off x="4764024" y="2834640"/>
+            <a:ext cx="1645920" cy="365760"/>
+          </a:xfrm>
+          <a:prstGeom prst="rect">
+            <a:avLst/>
+          </a:prstGeom>
+          <a:noFill/>
+          <a:ln/>
+        </p:spPr>
+        <p:txBody>
+          <a:bodyPr wrap="square" lIns="0" tIns="0" rIns="0" bIns="0" rtlCol="0" anchor="ctr"/>
+          <a:lstStyle/>
+          <a:p>
+            <a:pPr indent="0" marL="0">
+              <a:buNone/>
+            </a:pPr>
+            <a:r>
+              <a:rPr lang="en-US" sz="1300" b="1" dirty="0">
+                <a:solidFill>
+                  <a:schemeClr val="tx2"/>
+                </a:solidFill>
+              </a:rPr>
+              <a:t>Quorum: k of n, HSM</a:t>
+            </a:r>
+            <a:endParaRPr lang="en-US" sz="1300" dirty="0"/>
+          </a:p>
+        </p:txBody>
+      </p:sp>
+      <p:sp>
+        <p:nvSpPr>
+          <p:cNvPr id="15" name="Scale Full scale"/>
+          <p:cNvSpPr/>
+          <p:nvPr/>
+        </p:nvSpPr>
+        <p:spPr>
+          <a:xfrm>
+            <a:off x="6711696" y="1234440"/>
+            <a:ext cx="1920240" cy="2103120"/>
+          </a:xfrm>
+          <a:prstGeom prst="roundRect">
+            <a:avLst>
+              <a:gd name="adj" fmla="val 3810"/>
+            </a:avLst>
+          </a:prstGeom>
+          <a:solidFill>
+            <a:schemeClr val="bg2"/>
+          </a:solidFill>
+          <a:ln w="6350">
+            <a:solidFill>
+              <a:schemeClr val="bg2"/>
+            </a:solidFill>
+            <a:prstDash val="solid"/>
+          </a:ln>
+        </p:spPr>
+      </p:sp>
+      <p:sp>
+        <p:nvSpPr>
+          <p:cNvPr id="16" name="Text 14"/>
+          <p:cNvSpPr txBox="1"/>
+          <p:nvPr/>
+        </p:nvSpPr>
+        <p:spPr>
+          <a:xfrm>
+            <a:off x="6848856" y="1371600"/>
+            <a:ext cx="1645920" cy="365760"/>
+          </a:xfrm>
+          <a:prstGeom prst="rect">
+            <a:avLst/>
+          </a:prstGeom>
+          <a:noFill/>
+          <a:ln/>
+        </p:spPr>
+        <p:txBody>
+          <a:bodyPr wrap="square" lIns="0" tIns="0" rIns="0" bIns="0" rtlCol="0" anchor="ctr"/>
+          <a:lstStyle/>
+          <a:p>
+            <a:pPr indent="0" marL="0">
+              <a:buNone/>
+            </a:pPr>
+            <a:r>
+              <a:rPr lang="en-US" sz="1800" b="1" dirty="0">
+                <a:solidFill>
+                  <a:schemeClr val="accent4"/>
+                </a:solidFill>
+              </a:rPr>
+              <a:t>Full scale</a:t>
+            </a:r>
+            <a:endParaRPr lang="en-US" sz="1800" dirty="0"/>
+          </a:p>
+        </p:txBody>
+      </p:sp>
+      <p:sp>
+        <p:nvSpPr>
+          <p:cNvPr id="17" name="Text 15"/>
+          <p:cNvSpPr txBox="1"/>
+          <p:nvPr/>
+        </p:nvSpPr>
+        <p:spPr>
+          <a:xfrm>
+            <a:off x="6848856" y="1783080"/>
+            <a:ext cx="1645920" cy="1005840"/>
+          </a:xfrm>
+          <a:prstGeom prst="rect">
+            <a:avLst/>
+          </a:prstGeom>
+          <a:noFill/>
+          <a:ln/>
+        </p:spPr>
+        <p:txBody>
+          <a:bodyPr wrap="square" lIns="0" tIns="0" rIns="0" bIns="0" rtlCol="0" anchor="t"/>
+          <a:lstStyle/>
+          <a:p>
+            <a:pPr indent="0" marL="0">
+              <a:buNone/>
+            </a:pPr>
+            <a:r>
+              <a:rPr lang="en-US" sz="1400" dirty="0">
+                <a:solidFill>
+                  <a:schemeClr val="tx1"/>
+                </a:solidFill>
+              </a:rPr>
+              <a:t>Several entities proving policy to each other</a:t>
+            </a:r>
+            <a:endParaRPr lang="en-US" sz="1400" dirty="0"/>
+          </a:p>
+        </p:txBody>
+      </p:sp>
+      <p:sp>
+        <p:nvSpPr>
+          <p:cNvPr id="18" name="Text 16"/>
+          <p:cNvSpPr txBox="1"/>
+          <p:nvPr/>
+        </p:nvSpPr>
+        <p:spPr>
+          <a:xfrm>
+            <a:off x="6848856" y="2834640"/>
+            <a:ext cx="1645920" cy="365760"/>
+          </a:xfrm>
+          <a:prstGeom prst="rect">
+            <a:avLst/>
+          </a:prstGeom>
+          <a:noFill/>
+          <a:ln/>
+        </p:spPr>
+        <p:txBody>
+          <a:bodyPr wrap="square" lIns="0" tIns="0" rIns="0" bIns="0" rtlCol="0" anchor="ctr"/>
+          <a:lstStyle/>
+          <a:p>
+            <a:pPr indent="0" marL="0">
+              <a:buNone/>
+            </a:pPr>
+            <a:r>
+              <a:rPr lang="en-US" sz="1300" b="1" dirty="0">
+                <a:solidFill>
+                  <a:schemeClr val="tx2"/>
+                </a:solidFill>
+              </a:rPr>
+              <a:t>Quorum: Not started</a:t>
+            </a:r>
+            <a:endParaRPr lang="en-US" sz="1300" dirty="0"/>
+          </a:p>
+        </p:txBody>
+      </p:sp>
+      <p:sp>
+        <p:nvSpPr>
+          <p:cNvPr id="19" name="Text 17"/>
+          <p:cNvSpPr txBox="1"/>
+          <p:nvPr/>
+        </p:nvSpPr>
+        <p:spPr>
+          <a:xfrm>
+            <a:off x="457200" y="3566160"/>
+            <a:ext cx="8229600" cy="1005840"/>
+          </a:xfrm>
+          <a:prstGeom prst="rect">
+            <a:avLst/>
+          </a:prstGeom>
+          <a:noFill/>
+          <a:ln/>
+        </p:spPr>
+        <p:txBody>
+          <a:bodyPr wrap="square" lIns="0" tIns="0" rIns="0" bIns="0" rtlCol="0" anchor="t"/>
+          <a:lstStyle/>
+          <a:p>
+            <a:pPr indent="0" marL="0">
+              <a:buNone/>
+            </a:pPr>
+            <a:r>
               <a:rPr lang="en-US" sz="1600" dirty="0">
                 <a:solidFill>
-                  <a:schemeClr val="bg2"/>
-                </a:solidFill>
-              </a:rPr>
-              <a:t>Why open: a governance layer that must be trusted has to be inspectable. The evidence is executable, not a promise.</a:t>
+                  <a:schemeClr val="tx1"/>
+                </a:solidFill>
+              </a:rPr>
+              <a:t>Sensitive organizations start where their risk is, and raise the level without changing product. Installation guides for scales 1 and 2 are in the repository, with a verifiable success criterion per step.</a:t>
             </a:r>
             <a:endParaRPr lang="en-US" sz="1600" dirty="0"/>
+          </a:p>
+        </p:txBody>
+      </p:sp>
+      <p:sp>
+        <p:nvSpPr>
+          <p:cNvPr id="25" name="Slide Number Placeholder 0"/>
+          <p:cNvSpPr>
+            <a:spLocks noGrp="1"/>
+          </p:cNvSpPr>
+          <p:nvPr>
+            <p:ph type="sldNum" sz="quarter" idx="4294967295"/>
+          </p:nvPr>
+        </p:nvSpPr>
+        <p:spPr>
+          <a:xfrm>
+            <a:off x="8229600" y="4754880"/>
+            <a:ext cx="457200" cy="274320"/>
+          </a:xfrm>
+          <a:prstGeom prst="rect">
+            <a:avLst/>
+          </a:prstGeom>
+          <a:extLst>
+            <a:ext uri="{C572A759-6A51-4108-AA02-DFA0A04FC94B}">
+              <ma14:wrappingTextBoxFlag xmlns:ma14="http://schemas.microsoft.com/office/mac/drawingml/2011/main" val="0"/>
+            </a:ext>
+          </a:extLst>
+        </p:spPr>
+        <p:txBody>
+          <a:bodyPr/>
+          <a:lstStyle>
+            <a:lvl1pPr>
+              <a:defRPr sz="1000">
+                <a:solidFill>
+                  <a:schemeClr val="accent4"/>
+                </a:solidFill>
+              </a:defRPr>
+            </a:lvl1pPr>
+          </a:lstStyle>
+          <a:p>
+            <a:pPr algn="r"/>
+            <a:fld id="{F7021451-1387-4CA6-816F-3879F97B5CBC}" type="slidenum">
+              <a:rPr b="0" lang="en-US"/>
+              <a:t>10</a:t>
+            </a:fld>
+            <a:endParaRPr lang="en-US"/>
           </a:p>
         </p:txBody>
       </p:sp>
@@ -2723,10 +3290,10 @@
             <a:r>
               <a:rPr lang="en-US" sz="3000" b="1" dirty="0">
                 <a:solidFill>
-                  <a:schemeClr val="tx1"/>
-                </a:solidFill>
-              </a:rPr>
-              <a:t>Next: pilots, measurements, then certification</a:t>
+                  <a:schemeClr val="bg1"/>
+                </a:solidFill>
+              </a:rPr>
+              <a:t>Open protocol. Commercial product</a:t>
             </a:r>
             <a:endParaRPr lang="en-US" sz="3000" dirty="0"/>
           </a:p>
@@ -2734,26 +3301,26 @@
       </p:sp>
       <p:sp>
         <p:nvSpPr>
-          <p:cNvPr id="3" name="Next column"/>
+          <p:cNvPr id="3" name="Column 0"/>
           <p:cNvSpPr/>
           <p:nvPr/>
         </p:nvSpPr>
         <p:spPr>
           <a:xfrm>
-            <a:off x="457200" y="1188720"/>
-            <a:ext cx="4023360" cy="3200400"/>
+            <a:off x="457200" y="1371600"/>
+            <a:ext cx="4023360" cy="2011680"/>
           </a:xfrm>
           <a:prstGeom prst="roundRect">
             <a:avLst>
-              <a:gd name="adj" fmla="val 2286"/>
+              <a:gd name="adj" fmla="val 3636"/>
             </a:avLst>
           </a:prstGeom>
           <a:solidFill>
-            <a:schemeClr val="bg2"/>
+            <a:schemeClr val="tx2"/>
           </a:solidFill>
           <a:ln w="6350">
             <a:solidFill>
-              <a:schemeClr val="bg2"/>
+              <a:schemeClr val="tx2"/>
             </a:solidFill>
             <a:prstDash val="solid"/>
           </a:ln>
@@ -2767,8 +3334,8 @@
         </p:nvSpPr>
         <p:spPr>
           <a:xfrm>
-            <a:off x="640080" y="1298448"/>
-            <a:ext cx="3657600" cy="365760"/>
+            <a:off x="685800" y="1508760"/>
+            <a:ext cx="3566160" cy="457200"/>
           </a:xfrm>
           <a:prstGeom prst="rect">
             <a:avLst/>
@@ -2784,14 +3351,14 @@
               <a:buNone/>
             </a:pPr>
             <a:r>
-              <a:rPr lang="en-US" sz="1800" b="1" dirty="0">
-                <a:solidFill>
-                  <a:schemeClr val="accent1"/>
-                </a:solidFill>
-              </a:rPr>
-              <a:t>What the pre-seed funds</a:t>
-            </a:r>
-            <a:endParaRPr lang="en-US" sz="1800" dirty="0"/>
+              <a:rPr lang="en-US" sz="2000" b="1" dirty="0">
+                <a:solidFill>
+                  <a:schemeClr val="accent5"/>
+                </a:solidFill>
+              </a:rPr>
+              <a:t>TBP: open (Apache 2.0)</a:t>
+            </a:r>
+            <a:endParaRPr lang="en-US" sz="2000" dirty="0"/>
           </a:p>
         </p:txBody>
       </p:sp>
@@ -2803,8 +3370,8 @@
         </p:nvSpPr>
         <p:spPr>
           <a:xfrm>
-            <a:off x="640080" y="1737360"/>
-            <a:ext cx="3657600" cy="2560320"/>
+            <a:off x="685800" y="2057400"/>
+            <a:ext cx="3566160" cy="1188720"/>
           </a:xfrm>
           <a:prstGeom prst="rect">
             <a:avLst/>
@@ -2816,101 +3383,43 @@
           <a:bodyPr wrap="square" lIns="0" tIns="0" rIns="0" bIns="0" rtlCol="0" anchor="t"/>
           <a:lstStyle/>
           <a:p>
-            <a:pPr marL="342900" indent="-342900">
-              <a:spcAft>
-                <a:spcPts val="600"/>
-              </a:spcAft>
-              <a:buSzPct val="100000"/>
-              <a:buChar char="•"/>
-            </a:pPr>
-            <a:r>
-              <a:rPr lang="en-US" sz="1400" dirty="0">
-                <a:solidFill>
-                  <a:schemeClr val="tx1"/>
-                </a:solidFill>
-              </a:rPr>
-              <a:t>Scale 2 pilot on cloud, with the friction budget measured</a:t>
-            </a:r>
-            <a:endParaRPr lang="en-US" sz="1400" dirty="0"/>
-          </a:p>
-          <a:p>
-            <a:pPr marL="342900" indent="-342900">
-              <a:spcAft>
-                <a:spcPts val="600"/>
-              </a:spcAft>
-              <a:buSzPct val="100000"/>
-              <a:buChar char="•"/>
-            </a:pPr>
-            <a:r>
-              <a:rPr lang="en-US" sz="1400" dirty="0">
-                <a:solidFill>
-                  <a:schemeClr val="tx1"/>
-                </a:solidFill>
-              </a:rPr>
-              <a:t>Dynamic red-team campaign</a:t>
-            </a:r>
-            <a:endParaRPr lang="en-US" sz="1400" dirty="0"/>
-          </a:p>
-          <a:p>
-            <a:pPr marL="342900" indent="-342900">
-              <a:spcAft>
-                <a:spcPts val="600"/>
-              </a:spcAft>
-              <a:buSzPct val="100000"/>
-              <a:buChar char="•"/>
-            </a:pPr>
-            <a:r>
-              <a:rPr lang="en-US" sz="1400" dirty="0">
-                <a:solidFill>
-                  <a:schemeClr val="tx1"/>
-                </a:solidFill>
-              </a:rPr>
-              <a:t>First pilots with critical-infrastructure operators</a:t>
-            </a:r>
-            <a:endParaRPr lang="en-US" sz="1400" dirty="0"/>
-          </a:p>
-          <a:p>
-            <a:pPr marL="342900" indent="-342900">
-              <a:spcAft>
-                <a:spcPts val="600"/>
-              </a:spcAft>
-              <a:buSzPct val="100000"/>
-              <a:buChar char="•"/>
-            </a:pPr>
-            <a:r>
-              <a:rPr lang="en-US" sz="1400" dirty="0">
-                <a:solidFill>
-                  <a:schemeClr val="tx1"/>
-                </a:solidFill>
-              </a:rPr>
-              <a:t>External anchoring in production; behavioural profile across sequences</a:t>
-            </a:r>
-            <a:endParaRPr lang="en-US" sz="1400" dirty="0"/>
-          </a:p>
-        </p:txBody>
-      </p:sp>
-      <p:sp>
-        <p:nvSpPr>
-          <p:cNvPr id="6" name="Limits column"/>
+            <a:pPr indent="0" marL="0">
+              <a:buNone/>
+            </a:pPr>
+            <a:r>
+              <a:rPr lang="en-US" sz="1500" dirty="0">
+                <a:solidFill>
+                  <a:schemeClr val="bg1"/>
+                </a:solidFill>
+              </a:rPr>
+              <a:t>Protocol, reference implementation, selftest, deployment guides, compliance mappings. Anyone can read, run and audit it.</a:t>
+            </a:r>
+            <a:endParaRPr lang="en-US" sz="1500" dirty="0"/>
+          </a:p>
+        </p:txBody>
+      </p:sp>
+      <p:sp>
+        <p:nvSpPr>
+          <p:cNvPr id="6" name="Column 1"/>
           <p:cNvSpPr/>
           <p:nvPr/>
         </p:nvSpPr>
         <p:spPr>
           <a:xfrm>
-            <a:off x="4663440" y="1188720"/>
-            <a:ext cx="4023360" cy="3200400"/>
+            <a:off x="4663440" y="1371600"/>
+            <a:ext cx="4023360" cy="2011680"/>
           </a:xfrm>
           <a:prstGeom prst="roundRect">
             <a:avLst>
-              <a:gd name="adj" fmla="val 2286"/>
+              <a:gd name="adj" fmla="val 3636"/>
             </a:avLst>
           </a:prstGeom>
           <a:solidFill>
-            <a:schemeClr val="bg2"/>
+            <a:schemeClr val="tx2"/>
           </a:solidFill>
           <a:ln w="6350">
             <a:solidFill>
-              <a:schemeClr val="bg2"/>
+              <a:schemeClr val="tx2"/>
             </a:solidFill>
             <a:prstDash val="solid"/>
           </a:ln>
@@ -2924,8 +3433,8 @@
         </p:nvSpPr>
         <p:spPr>
           <a:xfrm>
-            <a:off x="4846320" y="1298448"/>
-            <a:ext cx="3657600" cy="365760"/>
+            <a:off x="4892040" y="1508760"/>
+            <a:ext cx="3566160" cy="457200"/>
           </a:xfrm>
           <a:prstGeom prst="rect">
             <a:avLst/>
@@ -2941,14 +3450,14 @@
               <a:buNone/>
             </a:pPr>
             <a:r>
-              <a:rPr lang="en-US" sz="1800" b="1" dirty="0">
-                <a:solidFill>
-                  <a:schemeClr val="accent3"/>
-                </a:solidFill>
-              </a:rPr>
-              <a:t>What we state openly</a:t>
-            </a:r>
-            <a:endParaRPr lang="en-US" sz="1800" dirty="0"/>
+              <a:rPr lang="en-US" sz="2000" b="1" dirty="0">
+                <a:solidFill>
+                  <a:schemeClr val="accent5"/>
+                </a:solidFill>
+              </a:rPr>
+              <a:t>INVARIAN: Avidost's product</a:t>
+            </a:r>
+            <a:endParaRPr lang="en-US" sz="2000" dirty="0"/>
           </a:p>
         </p:txBody>
       </p:sp>
@@ -2960,8 +3469,8 @@
         </p:nvSpPr>
         <p:spPr>
           <a:xfrm>
-            <a:off x="4846320" y="1737360"/>
-            <a:ext cx="3657600" cy="2560320"/>
+            <a:off x="4892040" y="2057400"/>
+            <a:ext cx="3566160" cy="1188720"/>
           </a:xfrm>
           <a:prstGeom prst="rect">
             <a:avLst/>
@@ -2973,121 +3482,54 @@
           <a:bodyPr wrap="square" lIns="0" tIns="0" rIns="0" bIns="0" rtlCol="0" anchor="t"/>
           <a:lstStyle/>
           <a:p>
-            <a:pPr marL="342900" indent="-342900">
-              <a:spcAft>
-                <a:spcPts val="600"/>
-              </a:spcAft>
-              <a:buSzPct val="100000"/>
-              <a:buChar char="•"/>
-            </a:pPr>
-            <a:r>
-              <a:rPr lang="en-US" sz="1400" dirty="0">
-                <a:solidFill>
-                  <a:schemeClr val="tx1"/>
-                </a:solidFill>
-              </a:rPr>
-              <a:t>No external certification or audit to date</a:t>
-            </a:r>
-            <a:endParaRPr lang="en-US" sz="1400" dirty="0"/>
-          </a:p>
-          <a:p>
-            <a:pPr marL="342900" indent="-342900">
-              <a:spcAft>
-                <a:spcPts val="600"/>
-              </a:spcAft>
-              <a:buSzPct val="100000"/>
-              <a:buChar char="•"/>
-            </a:pPr>
-            <a:r>
-              <a:rPr lang="en-US" sz="1400" dirty="0">
-                <a:solidFill>
-                  <a:schemeClr val="tx1"/>
-                </a:solidFill>
-              </a:rPr>
-              <a:t>TBP does not judge the model's reasoning or check facts</a:t>
-            </a:r>
-            <a:endParaRPr lang="en-US" sz="1400" dirty="0"/>
-          </a:p>
-          <a:p>
-            <a:pPr marL="342900" indent="-342900">
-              <a:spcAft>
-                <a:spcPts val="600"/>
-              </a:spcAft>
-              <a:buSzPct val="100000"/>
-              <a:buChar char="•"/>
-            </a:pPr>
-            <a:r>
-              <a:rPr lang="en-US" sz="1400" dirty="0">
-                <a:solidFill>
-                  <a:schemeClr val="tx1"/>
-                </a:solidFill>
-              </a:rPr>
-              <a:t>It protects what goes through it; it adds to, not replaces, other security controls</a:t>
-            </a:r>
-            <a:endParaRPr lang="en-US" sz="1400" dirty="0"/>
-          </a:p>
-          <a:p>
-            <a:pPr marL="342900" indent="-342900">
-              <a:spcAft>
-                <a:spcPts val="600"/>
-              </a:spcAft>
-              <a:buSzPct val="100000"/>
-              <a:buChar char="•"/>
-            </a:pPr>
-            <a:r>
-              <a:rPr lang="en-US" sz="1400" dirty="0">
-                <a:solidFill>
-                  <a:schemeClr val="tx1"/>
-                </a:solidFill>
-              </a:rPr>
-              <a:t>Validation lab and first pilots are under way</a:t>
-            </a:r>
-            <a:endParaRPr lang="en-US" sz="1400" dirty="0"/>
-          </a:p>
-        </p:txBody>
-      </p:sp>
-      <p:sp>
-        <p:nvSpPr>
-          <p:cNvPr id="25" name="Slide Number Placeholder 0"/>
-          <p:cNvSpPr>
-            <a:spLocks noGrp="1"/>
-          </p:cNvSpPr>
-          <p:nvPr>
-            <p:ph type="sldNum" sz="quarter" idx="4294967295"/>
-          </p:nvPr>
-        </p:nvSpPr>
-        <p:spPr>
-          <a:xfrm>
-            <a:off x="8229600" y="4754880"/>
-            <a:ext cx="457200" cy="274320"/>
-          </a:xfrm>
-          <a:prstGeom prst="rect">
-            <a:avLst/>
-          </a:prstGeom>
-          <a:extLst>
-            <a:ext uri="{C572A759-6A51-4108-AA02-DFA0A04FC94B}">
-              <ma14:wrappingTextBoxFlag xmlns:ma14="http://schemas.microsoft.com/office/mac/drawingml/2011/main" val="0"/>
-            </a:ext>
-          </a:extLst>
-        </p:spPr>
-        <p:txBody>
-          <a:bodyPr/>
-          <a:lstStyle>
-            <a:lvl1pPr>
-              <a:defRPr sz="1000">
-                <a:solidFill>
-                  <a:schemeClr val="accent4"/>
-                </a:solidFill>
-              </a:defRPr>
-            </a:lvl1pPr>
-          </a:lstStyle>
-          <a:p>
-            <a:pPr algn="r"/>
-            <a:fld id="{F7021451-1387-4CA6-816F-3879F97B5CBC}" type="slidenum">
-              <a:rPr b="0" lang="en-US"/>
-              <a:t>11</a:t>
-            </a:fld>
-            <a:endParaRPr lang="en-US"/>
+            <a:pPr indent="0" marL="0">
+              <a:buNone/>
+            </a:pPr>
+            <a:r>
+              <a:rPr lang="en-US" sz="1500" dirty="0">
+                <a:solidFill>
+                  <a:schemeClr val="bg1"/>
+                </a:solidFill>
+              </a:rPr>
+              <a:t>Built on TBP for organizations that must demonstrate control: sensitive sectors and teams preparing for EU AI Act obligations.</a:t>
+            </a:r>
+            <a:endParaRPr lang="en-US" sz="1500" dirty="0"/>
+          </a:p>
+        </p:txBody>
+      </p:sp>
+      <p:sp>
+        <p:nvSpPr>
+          <p:cNvPr id="9" name="Text 7"/>
+          <p:cNvSpPr txBox="1"/>
+          <p:nvPr/>
+        </p:nvSpPr>
+        <p:spPr>
+          <a:xfrm>
+            <a:off x="457200" y="3657600"/>
+            <a:ext cx="8229600" cy="822960"/>
+          </a:xfrm>
+          <a:prstGeom prst="rect">
+            <a:avLst/>
+          </a:prstGeom>
+          <a:noFill/>
+          <a:ln/>
+        </p:spPr>
+        <p:txBody>
+          <a:bodyPr wrap="square" lIns="0" tIns="0" rIns="0" bIns="0" rtlCol="0" anchor="t"/>
+          <a:lstStyle/>
+          <a:p>
+            <a:pPr indent="0" marL="0">
+              <a:buNone/>
+            </a:pPr>
+            <a:r>
+              <a:rPr lang="en-US" sz="1600" dirty="0">
+                <a:solidFill>
+                  <a:schemeClr val="bg2"/>
+                </a:solidFill>
+              </a:rPr>
+              <a:t>Why open: a governance layer that must be trusted has to be inspectable. The evidence is executable, not a promise.</a:t>
+            </a:r>
+            <a:endParaRPr lang="en-US" sz="1600" dirty="0"/>
           </a:p>
         </p:txBody>
       </p:sp>
@@ -3102,6 +3544,968 @@
 <file path=ppt/slides/slide12.xml><?xml version="1.0" encoding="utf-8"?>
 <p:sld xmlns:a="http://schemas.openxmlformats.org/drawingml/2006/main" xmlns:r="http://schemas.openxmlformats.org/officeDocument/2006/relationships" xmlns:p="http://schemas.openxmlformats.org/presentationml/2006/main">
   <p:cSld name="Slide 12">
+    <p:spTree>
+      <p:nvGrpSpPr>
+        <p:cNvPr id="1" name=""/>
+        <p:cNvGrpSpPr/>
+        <p:nvPr/>
+      </p:nvGrpSpPr>
+      <p:grpSpPr>
+        <a:xfrm>
+          <a:off x="0" y="0"/>
+          <a:ext cx="0" cy="0"/>
+          <a:chOff x="0" y="0"/>
+          <a:chExt cx="0" cy="0"/>
+        </a:xfrm>
+      </p:grpSpPr>
+      <p:sp>
+        <p:nvSpPr>
+          <p:cNvPr id="2" name="Text 0"/>
+          <p:cNvSpPr/>
+          <p:nvPr>
+            <p:ph idx="100" type="title" hasCustomPrompt="1"/>
+          </p:nvPr>
+        </p:nvSpPr>
+        <p:spPr>
+          <a:xfrm>
+            <a:off x="457200" y="320040"/>
+            <a:ext cx="8229600" cy="731520"/>
+          </a:xfrm>
+          <a:prstGeom prst="rect">
+            <a:avLst/>
+          </a:prstGeom>
+          <a:noFill/>
+          <a:ln/>
+        </p:spPr>
+        <p:txBody>
+          <a:bodyPr wrap="square" lIns="0" tIns="0" rIns="0" bIns="0" rtlCol="0" anchor="t"/>
+          <a:lstStyle/>
+          <a:p>
+            <a:pPr algn="l" indent="0" marL="0">
+              <a:buNone/>
+            </a:pPr>
+            <a:r>
+              <a:rPr lang="en-US" sz="3000" b="1" dirty="0">
+                <a:solidFill>
+                  <a:schemeClr val="tx1"/>
+                </a:solidFill>
+              </a:rPr>
+              <a:t>Next: pilots, measurements, then certification</a:t>
+            </a:r>
+            <a:endParaRPr lang="en-US" sz="3000" dirty="0"/>
+          </a:p>
+        </p:txBody>
+      </p:sp>
+      <p:sp>
+        <p:nvSpPr>
+          <p:cNvPr id="3" name="Next column"/>
+          <p:cNvSpPr/>
+          <p:nvPr/>
+        </p:nvSpPr>
+        <p:spPr>
+          <a:xfrm>
+            <a:off x="457200" y="1188720"/>
+            <a:ext cx="4023360" cy="3200400"/>
+          </a:xfrm>
+          <a:prstGeom prst="roundRect">
+            <a:avLst>
+              <a:gd name="adj" fmla="val 2286"/>
+            </a:avLst>
+          </a:prstGeom>
+          <a:solidFill>
+            <a:schemeClr val="bg2"/>
+          </a:solidFill>
+          <a:ln w="6350">
+            <a:solidFill>
+              <a:schemeClr val="bg2"/>
+            </a:solidFill>
+            <a:prstDash val="solid"/>
+          </a:ln>
+        </p:spPr>
+      </p:sp>
+      <p:sp>
+        <p:nvSpPr>
+          <p:cNvPr id="4" name="Text 2"/>
+          <p:cNvSpPr txBox="1"/>
+          <p:nvPr/>
+        </p:nvSpPr>
+        <p:spPr>
+          <a:xfrm>
+            <a:off x="640080" y="1298448"/>
+            <a:ext cx="3657600" cy="365760"/>
+          </a:xfrm>
+          <a:prstGeom prst="rect">
+            <a:avLst/>
+          </a:prstGeom>
+          <a:noFill/>
+          <a:ln/>
+        </p:spPr>
+        <p:txBody>
+          <a:bodyPr wrap="square" lIns="0" tIns="0" rIns="0" bIns="0" rtlCol="0" anchor="ctr"/>
+          <a:lstStyle/>
+          <a:p>
+            <a:pPr indent="0" marL="0">
+              <a:buNone/>
+            </a:pPr>
+            <a:r>
+              <a:rPr lang="en-US" sz="1800" b="1" dirty="0">
+                <a:solidFill>
+                  <a:schemeClr val="accent1"/>
+                </a:solidFill>
+              </a:rPr>
+              <a:t>What the pre-seed funds</a:t>
+            </a:r>
+            <a:endParaRPr lang="en-US" sz="1800" dirty="0"/>
+          </a:p>
+        </p:txBody>
+      </p:sp>
+      <p:sp>
+        <p:nvSpPr>
+          <p:cNvPr id="5" name="Text 3"/>
+          <p:cNvSpPr txBox="1"/>
+          <p:nvPr/>
+        </p:nvSpPr>
+        <p:spPr>
+          <a:xfrm>
+            <a:off x="640080" y="1737360"/>
+            <a:ext cx="3657600" cy="2560320"/>
+          </a:xfrm>
+          <a:prstGeom prst="rect">
+            <a:avLst/>
+          </a:prstGeom>
+          <a:noFill/>
+          <a:ln/>
+        </p:spPr>
+        <p:txBody>
+          <a:bodyPr wrap="square" lIns="0" tIns="0" rIns="0" bIns="0" rtlCol="0" anchor="t"/>
+          <a:lstStyle/>
+          <a:p>
+            <a:pPr marL="342900" indent="-342900">
+              <a:spcAft>
+                <a:spcPts val="600"/>
+              </a:spcAft>
+              <a:buSzPct val="100000"/>
+              <a:buChar char="•"/>
+            </a:pPr>
+            <a:r>
+              <a:rPr lang="en-US" sz="1400" dirty="0">
+                <a:solidFill>
+                  <a:schemeClr val="tx1"/>
+                </a:solidFill>
+              </a:rPr>
+              <a:t>Scale 2 pilot on cloud, with the friction budget measured</a:t>
+            </a:r>
+            <a:endParaRPr lang="en-US" sz="1400" dirty="0"/>
+          </a:p>
+          <a:p>
+            <a:pPr marL="342900" indent="-342900">
+              <a:spcAft>
+                <a:spcPts val="600"/>
+              </a:spcAft>
+              <a:buSzPct val="100000"/>
+              <a:buChar char="•"/>
+            </a:pPr>
+            <a:r>
+              <a:rPr lang="en-US" sz="1400" dirty="0">
+                <a:solidFill>
+                  <a:schemeClr val="tx1"/>
+                </a:solidFill>
+              </a:rPr>
+              <a:t>Dynamic red-team campaign</a:t>
+            </a:r>
+            <a:endParaRPr lang="en-US" sz="1400" dirty="0"/>
+          </a:p>
+          <a:p>
+            <a:pPr marL="342900" indent="-342900">
+              <a:spcAft>
+                <a:spcPts val="600"/>
+              </a:spcAft>
+              <a:buSzPct val="100000"/>
+              <a:buChar char="•"/>
+            </a:pPr>
+            <a:r>
+              <a:rPr lang="en-US" sz="1400" dirty="0">
+                <a:solidFill>
+                  <a:schemeClr val="tx1"/>
+                </a:solidFill>
+              </a:rPr>
+              <a:t>First pilots with critical-infrastructure operators</a:t>
+            </a:r>
+            <a:endParaRPr lang="en-US" sz="1400" dirty="0"/>
+          </a:p>
+          <a:p>
+            <a:pPr marL="342900" indent="-342900">
+              <a:spcAft>
+                <a:spcPts val="600"/>
+              </a:spcAft>
+              <a:buSzPct val="100000"/>
+              <a:buChar char="•"/>
+            </a:pPr>
+            <a:r>
+              <a:rPr lang="en-US" sz="1400" dirty="0">
+                <a:solidFill>
+                  <a:schemeClr val="tx1"/>
+                </a:solidFill>
+              </a:rPr>
+              <a:t>External anchoring in production; behavioural profile across sequences</a:t>
+            </a:r>
+            <a:endParaRPr lang="en-US" sz="1400" dirty="0"/>
+          </a:p>
+        </p:txBody>
+      </p:sp>
+      <p:sp>
+        <p:nvSpPr>
+          <p:cNvPr id="6" name="Limits column"/>
+          <p:cNvSpPr/>
+          <p:nvPr/>
+        </p:nvSpPr>
+        <p:spPr>
+          <a:xfrm>
+            <a:off x="4663440" y="1188720"/>
+            <a:ext cx="4023360" cy="3200400"/>
+          </a:xfrm>
+          <a:prstGeom prst="roundRect">
+            <a:avLst>
+              <a:gd name="adj" fmla="val 2286"/>
+            </a:avLst>
+          </a:prstGeom>
+          <a:solidFill>
+            <a:schemeClr val="bg2"/>
+          </a:solidFill>
+          <a:ln w="6350">
+            <a:solidFill>
+              <a:schemeClr val="bg2"/>
+            </a:solidFill>
+            <a:prstDash val="solid"/>
+          </a:ln>
+        </p:spPr>
+      </p:sp>
+      <p:sp>
+        <p:nvSpPr>
+          <p:cNvPr id="7" name="Text 5"/>
+          <p:cNvSpPr txBox="1"/>
+          <p:nvPr/>
+        </p:nvSpPr>
+        <p:spPr>
+          <a:xfrm>
+            <a:off x="4846320" y="1298448"/>
+            <a:ext cx="3657600" cy="365760"/>
+          </a:xfrm>
+          <a:prstGeom prst="rect">
+            <a:avLst/>
+          </a:prstGeom>
+          <a:noFill/>
+          <a:ln/>
+        </p:spPr>
+        <p:txBody>
+          <a:bodyPr wrap="square" lIns="0" tIns="0" rIns="0" bIns="0" rtlCol="0" anchor="ctr"/>
+          <a:lstStyle/>
+          <a:p>
+            <a:pPr indent="0" marL="0">
+              <a:buNone/>
+            </a:pPr>
+            <a:r>
+              <a:rPr lang="en-US" sz="1800" b="1" dirty="0">
+                <a:solidFill>
+                  <a:schemeClr val="accent3"/>
+                </a:solidFill>
+              </a:rPr>
+              <a:t>What we state openly</a:t>
+            </a:r>
+            <a:endParaRPr lang="en-US" sz="1800" dirty="0"/>
+          </a:p>
+        </p:txBody>
+      </p:sp>
+      <p:sp>
+        <p:nvSpPr>
+          <p:cNvPr id="8" name="Text 6"/>
+          <p:cNvSpPr txBox="1"/>
+          <p:nvPr/>
+        </p:nvSpPr>
+        <p:spPr>
+          <a:xfrm>
+            <a:off x="4846320" y="1737360"/>
+            <a:ext cx="3657600" cy="2560320"/>
+          </a:xfrm>
+          <a:prstGeom prst="rect">
+            <a:avLst/>
+          </a:prstGeom>
+          <a:noFill/>
+          <a:ln/>
+        </p:spPr>
+        <p:txBody>
+          <a:bodyPr wrap="square" lIns="0" tIns="0" rIns="0" bIns="0" rtlCol="0" anchor="t"/>
+          <a:lstStyle/>
+          <a:p>
+            <a:pPr marL="342900" indent="-342900">
+              <a:spcAft>
+                <a:spcPts val="600"/>
+              </a:spcAft>
+              <a:buSzPct val="100000"/>
+              <a:buChar char="•"/>
+            </a:pPr>
+            <a:r>
+              <a:rPr lang="en-US" sz="1400" dirty="0">
+                <a:solidFill>
+                  <a:schemeClr val="tx1"/>
+                </a:solidFill>
+              </a:rPr>
+              <a:t>No external certification or audit to date</a:t>
+            </a:r>
+            <a:endParaRPr lang="en-US" sz="1400" dirty="0"/>
+          </a:p>
+          <a:p>
+            <a:pPr marL="342900" indent="-342900">
+              <a:spcAft>
+                <a:spcPts val="600"/>
+              </a:spcAft>
+              <a:buSzPct val="100000"/>
+              <a:buChar char="•"/>
+            </a:pPr>
+            <a:r>
+              <a:rPr lang="en-US" sz="1400" dirty="0">
+                <a:solidFill>
+                  <a:schemeClr val="tx1"/>
+                </a:solidFill>
+              </a:rPr>
+              <a:t>TBP does not judge the model's reasoning or check facts</a:t>
+            </a:r>
+            <a:endParaRPr lang="en-US" sz="1400" dirty="0"/>
+          </a:p>
+          <a:p>
+            <a:pPr marL="342900" indent="-342900">
+              <a:spcAft>
+                <a:spcPts val="600"/>
+              </a:spcAft>
+              <a:buSzPct val="100000"/>
+              <a:buChar char="•"/>
+            </a:pPr>
+            <a:r>
+              <a:rPr lang="en-US" sz="1400" dirty="0">
+                <a:solidFill>
+                  <a:schemeClr val="tx1"/>
+                </a:solidFill>
+              </a:rPr>
+              <a:t>It protects what goes through it; it adds to, not replaces, other security controls</a:t>
+            </a:r>
+            <a:endParaRPr lang="en-US" sz="1400" dirty="0"/>
+          </a:p>
+          <a:p>
+            <a:pPr marL="342900" indent="-342900">
+              <a:spcAft>
+                <a:spcPts val="600"/>
+              </a:spcAft>
+              <a:buSzPct val="100000"/>
+              <a:buChar char="•"/>
+            </a:pPr>
+            <a:r>
+              <a:rPr lang="en-US" sz="1400" dirty="0">
+                <a:solidFill>
+                  <a:schemeClr val="tx1"/>
+                </a:solidFill>
+              </a:rPr>
+              <a:t>Validation lab and first pilots are under way</a:t>
+            </a:r>
+            <a:endParaRPr lang="en-US" sz="1400" dirty="0"/>
+          </a:p>
+        </p:txBody>
+      </p:sp>
+      <p:sp>
+        <p:nvSpPr>
+          <p:cNvPr id="25" name="Slide Number Placeholder 0"/>
+          <p:cNvSpPr>
+            <a:spLocks noGrp="1"/>
+          </p:cNvSpPr>
+          <p:nvPr>
+            <p:ph type="sldNum" sz="quarter" idx="4294967295"/>
+          </p:nvPr>
+        </p:nvSpPr>
+        <p:spPr>
+          <a:xfrm>
+            <a:off x="8229600" y="4754880"/>
+            <a:ext cx="457200" cy="274320"/>
+          </a:xfrm>
+          <a:prstGeom prst="rect">
+            <a:avLst/>
+          </a:prstGeom>
+          <a:extLst>
+            <a:ext uri="{C572A759-6A51-4108-AA02-DFA0A04FC94B}">
+              <ma14:wrappingTextBoxFlag xmlns:ma14="http://schemas.microsoft.com/office/mac/drawingml/2011/main" val="0"/>
+            </a:ext>
+          </a:extLst>
+        </p:spPr>
+        <p:txBody>
+          <a:bodyPr/>
+          <a:lstStyle>
+            <a:lvl1pPr>
+              <a:defRPr sz="1000">
+                <a:solidFill>
+                  <a:schemeClr val="accent4"/>
+                </a:solidFill>
+              </a:defRPr>
+            </a:lvl1pPr>
+          </a:lstStyle>
+          <a:p>
+            <a:pPr algn="r"/>
+            <a:fld id="{F7021451-1387-4CA6-816F-3879F97B5CBC}" type="slidenum">
+              <a:rPr b="0" lang="en-US"/>
+              <a:t>12</a:t>
+            </a:fld>
+            <a:endParaRPr lang="en-US"/>
+          </a:p>
+        </p:txBody>
+      </p:sp>
+    </p:spTree>
+  </p:cSld>
+  <p:clrMapOvr>
+    <a:masterClrMapping/>
+  </p:clrMapOvr>
+</p:sld>
+</file>
+
+<file path=ppt/slides/slide13.xml><?xml version="1.0" encoding="utf-8"?>
+<p:sld xmlns:a="http://schemas.openxmlformats.org/drawingml/2006/main" xmlns:r="http://schemas.openxmlformats.org/officeDocument/2006/relationships" xmlns:p="http://schemas.openxmlformats.org/presentationml/2006/main">
+  <p:cSld name="Slide 13">
+    <p:spTree>
+      <p:nvGrpSpPr>
+        <p:cNvPr id="1" name=""/>
+        <p:cNvGrpSpPr/>
+        <p:nvPr/>
+      </p:nvGrpSpPr>
+      <p:grpSpPr>
+        <a:xfrm>
+          <a:off x="0" y="0"/>
+          <a:ext cx="0" cy="0"/>
+          <a:chOff x="0" y="0"/>
+          <a:chExt cx="0" cy="0"/>
+        </a:xfrm>
+      </p:grpSpPr>
+      <p:sp>
+        <p:nvSpPr>
+          <p:cNvPr id="2" name="Text 0"/>
+          <p:cNvSpPr/>
+          <p:nvPr>
+            <p:ph idx="100" type="title" hasCustomPrompt="1"/>
+          </p:nvPr>
+        </p:nvSpPr>
+        <p:spPr>
+          <a:xfrm>
+            <a:off x="457200" y="320040"/>
+            <a:ext cx="8229600" cy="731520"/>
+          </a:xfrm>
+          <a:prstGeom prst="rect">
+            <a:avLst/>
+          </a:prstGeom>
+          <a:noFill/>
+          <a:ln/>
+        </p:spPr>
+        <p:txBody>
+          <a:bodyPr wrap="square" lIns="0" tIns="0" rIns="0" bIns="0" rtlCol="0" anchor="t"/>
+          <a:lstStyle/>
+          <a:p>
+            <a:pPr algn="l" indent="0" marL="0">
+              <a:buNone/>
+            </a:pPr>
+            <a:r>
+              <a:rPr lang="en-US" sz="3000" b="1" dirty="0">
+                <a:solidFill>
+                  <a:schemeClr val="tx1"/>
+                </a:solidFill>
+              </a:rPr>
+              <a:t>Learn more</a:t>
+            </a:r>
+            <a:endParaRPr lang="en-US" sz="3000" dirty="0"/>
+          </a:p>
+        </p:txBody>
+      </p:sp>
+      <p:sp>
+        <p:nvSpPr>
+          <p:cNvPr id="3" name="Link Whitepaper"/>
+          <p:cNvSpPr/>
+          <p:nvPr/>
+        </p:nvSpPr>
+        <p:spPr>
+          <a:xfrm>
+            <a:off x="457200" y="1188720"/>
+            <a:ext cx="8229600" cy="868680"/>
+          </a:xfrm>
+          <a:prstGeom prst="roundRect">
+            <a:avLst>
+              <a:gd name="adj" fmla="val 8421"/>
+            </a:avLst>
+          </a:prstGeom>
+          <a:solidFill>
+            <a:schemeClr val="bg2"/>
+          </a:solidFill>
+          <a:ln w="6350">
+            <a:solidFill>
+              <a:schemeClr val="bg2"/>
+            </a:solidFill>
+            <a:prstDash val="solid"/>
+          </a:ln>
+        </p:spPr>
+      </p:sp>
+      <p:sp>
+        <p:nvSpPr>
+          <p:cNvPr id="4" name="Text 2"/>
+          <p:cNvSpPr txBox="1"/>
+          <p:nvPr/>
+        </p:nvSpPr>
+        <p:spPr>
+          <a:xfrm>
+            <a:off x="685800" y="1261872"/>
+            <a:ext cx="7772400" cy="320040"/>
+          </a:xfrm>
+          <a:prstGeom prst="rect">
+            <a:avLst/>
+          </a:prstGeom>
+          <a:noFill/>
+          <a:ln/>
+        </p:spPr>
+        <p:txBody>
+          <a:bodyPr wrap="square" lIns="0" tIns="0" rIns="0" bIns="0" rtlCol="0" anchor="ctr"/>
+          <a:lstStyle/>
+          <a:p>
+            <a:pPr indent="0" marL="0">
+              <a:buNone/>
+            </a:pPr>
+            <a:r>
+              <a:rPr lang="en-US" sz="1800" b="1" dirty="0">
+                <a:solidFill>
+                  <a:schemeClr val="tx1"/>
+                </a:solidFill>
+              </a:rPr>
+              <a:t>Whitepaper</a:t>
+            </a:r>
+            <a:endParaRPr lang="en-US" sz="1800" dirty="0"/>
+          </a:p>
+        </p:txBody>
+      </p:sp>
+      <p:sp>
+        <p:nvSpPr>
+          <p:cNvPr id="5" name="Text 3"/>
+          <p:cNvSpPr txBox="1"/>
+          <p:nvPr/>
+        </p:nvSpPr>
+        <p:spPr>
+          <a:xfrm>
+            <a:off x="685800" y="1572768"/>
+            <a:ext cx="7772400" cy="228600"/>
+          </a:xfrm>
+          <a:prstGeom prst="rect">
+            <a:avLst/>
+          </a:prstGeom>
+          <a:noFill/>
+          <a:ln/>
+        </p:spPr>
+        <p:txBody>
+          <a:bodyPr wrap="square" lIns="0" tIns="0" rIns="0" bIns="0" rtlCol="0" anchor="ctr"/>
+          <a:lstStyle/>
+          <a:p>
+            <a:pPr indent="0" marL="0">
+              <a:buNone/>
+            </a:pPr>
+            <a:r>
+              <a:rPr lang="en-US" sz="1200" dirty="0">
+                <a:solidFill>
+                  <a:schemeClr val="tx2"/>
+                </a:solidFill>
+              </a:rPr>
+              <a:t>AI Agent Governance: Proof, Not Promises (12 pages, dated figures, sources)</a:t>
+            </a:r>
+            <a:endParaRPr lang="en-US" sz="1200" dirty="0"/>
+          </a:p>
+        </p:txBody>
+      </p:sp>
+      <p:sp>
+        <p:nvSpPr>
+          <p:cNvPr id="6" name="Text 4">
+            <a:hlinkClick r:id="rId1" tooltip="Whitepaper"/>
+          </p:cNvPr>
+          <p:cNvSpPr txBox="1"/>
+          <p:nvPr/>
+        </p:nvSpPr>
+        <p:spPr>
+          <a:xfrm>
+            <a:off x="685800" y="1792224"/>
+            <a:ext cx="7772400" cy="228600"/>
+          </a:xfrm>
+          <a:prstGeom prst="rect">
+            <a:avLst/>
+          </a:prstGeom>
+          <a:noFill/>
+          <a:ln/>
+        </p:spPr>
+        <p:txBody>
+          <a:bodyPr wrap="square" lIns="0" tIns="0" rIns="0" bIns="0" rtlCol="0" anchor="ctr"/>
+          <a:lstStyle/>
+          <a:p>
+            <a:pPr indent="0" marL="0">
+              <a:buNone/>
+            </a:pPr>
+            <a:r>
+              <a:rPr lang="en-US" sz="1200" u="sng" dirty="0">
+                <a:solidFill>
+                  <a:schemeClr val="accent1"/>
+                </a:solidFill>
+                <a:hlinkClick r:id="rId1" invalidUrl="" action="" tgtFrame="" tooltip="Whitepaper" history="1" highlightClick="0" endSnd="0">
+                  <a:extLst>
+                    <a:ext uri="{A12FA001-AC4F-418D-AE19-62706E023703}">
+                      <ahyp:hlinkClr xmlns:ahyp="http://schemas.microsoft.com/office/drawing/2018/hyperlinkcolor" val="tx"/>
+                    </a:ext>
+                  </a:extLst>
+                </a:hlinkClick>
+              </a:rPr>
+              <a:t>avidost.fr/INVARIAN-Whitepaper-TBP-EN.pdf</a:t>
+            </a:r>
+            <a:endParaRPr lang="en-US" sz="1200" dirty="0"/>
+          </a:p>
+        </p:txBody>
+      </p:sp>
+      <p:sp>
+        <p:nvSpPr>
+          <p:cNvPr id="7" name="Link Open-source repository"/>
+          <p:cNvSpPr/>
+          <p:nvPr/>
+        </p:nvSpPr>
+        <p:spPr>
+          <a:xfrm>
+            <a:off x="457200" y="2194560"/>
+            <a:ext cx="8229600" cy="868680"/>
+          </a:xfrm>
+          <a:prstGeom prst="roundRect">
+            <a:avLst>
+              <a:gd name="adj" fmla="val 8421"/>
+            </a:avLst>
+          </a:prstGeom>
+          <a:solidFill>
+            <a:schemeClr val="bg2"/>
+          </a:solidFill>
+          <a:ln w="6350">
+            <a:solidFill>
+              <a:schemeClr val="bg2"/>
+            </a:solidFill>
+            <a:prstDash val="solid"/>
+          </a:ln>
+        </p:spPr>
+      </p:sp>
+      <p:sp>
+        <p:nvSpPr>
+          <p:cNvPr id="8" name="Text 6"/>
+          <p:cNvSpPr txBox="1"/>
+          <p:nvPr/>
+        </p:nvSpPr>
+        <p:spPr>
+          <a:xfrm>
+            <a:off x="685800" y="2267712"/>
+            <a:ext cx="7772400" cy="320040"/>
+          </a:xfrm>
+          <a:prstGeom prst="rect">
+            <a:avLst/>
+          </a:prstGeom>
+          <a:noFill/>
+          <a:ln/>
+        </p:spPr>
+        <p:txBody>
+          <a:bodyPr wrap="square" lIns="0" tIns="0" rIns="0" bIns="0" rtlCol="0" anchor="ctr"/>
+          <a:lstStyle/>
+          <a:p>
+            <a:pPr indent="0" marL="0">
+              <a:buNone/>
+            </a:pPr>
+            <a:r>
+              <a:rPr lang="en-US" sz="1800" b="1" dirty="0">
+                <a:solidFill>
+                  <a:schemeClr val="tx1"/>
+                </a:solidFill>
+              </a:rPr>
+              <a:t>Open-source repository</a:t>
+            </a:r>
+            <a:endParaRPr lang="en-US" sz="1800" dirty="0"/>
+          </a:p>
+        </p:txBody>
+      </p:sp>
+      <p:sp>
+        <p:nvSpPr>
+          <p:cNvPr id="9" name="Text 7"/>
+          <p:cNvSpPr txBox="1"/>
+          <p:nvPr/>
+        </p:nvSpPr>
+        <p:spPr>
+          <a:xfrm>
+            <a:off x="685800" y="2578608"/>
+            <a:ext cx="7772400" cy="228600"/>
+          </a:xfrm>
+          <a:prstGeom prst="rect">
+            <a:avLst/>
+          </a:prstGeom>
+          <a:noFill/>
+          <a:ln/>
+        </p:spPr>
+        <p:txBody>
+          <a:bodyPr wrap="square" lIns="0" tIns="0" rIns="0" bIns="0" rtlCol="0" anchor="ctr"/>
+          <a:lstStyle/>
+          <a:p>
+            <a:pPr indent="0" marL="0">
+              <a:buNone/>
+            </a:pPr>
+            <a:r>
+              <a:rPr lang="en-US" sz="1200" dirty="0">
+                <a:solidFill>
+                  <a:schemeClr val="tx2"/>
+                </a:solidFill>
+              </a:rPr>
+              <a:t>TBP-NETWORK: code, selftest, deployment guides, compliance mappings (Apache 2.0)</a:t>
+            </a:r>
+            <a:endParaRPr lang="en-US" sz="1200" dirty="0"/>
+          </a:p>
+        </p:txBody>
+      </p:sp>
+      <p:sp>
+        <p:nvSpPr>
+          <p:cNvPr id="10" name="Text 8">
+            <a:hlinkClick r:id="rId2" tooltip="Open-source repository"/>
+          </p:cNvPr>
+          <p:cNvSpPr txBox="1"/>
+          <p:nvPr/>
+        </p:nvSpPr>
+        <p:spPr>
+          <a:xfrm>
+            <a:off x="685800" y="2798064"/>
+            <a:ext cx="7772400" cy="228600"/>
+          </a:xfrm>
+          <a:prstGeom prst="rect">
+            <a:avLst/>
+          </a:prstGeom>
+          <a:noFill/>
+          <a:ln/>
+        </p:spPr>
+        <p:txBody>
+          <a:bodyPr wrap="square" lIns="0" tIns="0" rIns="0" bIns="0" rtlCol="0" anchor="ctr"/>
+          <a:lstStyle/>
+          <a:p>
+            <a:pPr indent="0" marL="0">
+              <a:buNone/>
+            </a:pPr>
+            <a:r>
+              <a:rPr lang="en-US" sz="1200" u="sng" dirty="0">
+                <a:solidFill>
+                  <a:schemeClr val="accent1"/>
+                </a:solidFill>
+                <a:hlinkClick r:id="rId2" invalidUrl="" action="" tgtFrame="" tooltip="Open-source repository" history="1" highlightClick="0" endSnd="0">
+                  <a:extLst>
+                    <a:ext uri="{A12FA001-AC4F-418D-AE19-62706E023703}">
+                      <ahyp:hlinkClr xmlns:ahyp="http://schemas.microsoft.com/office/drawing/2018/hyperlinkcolor" val="tx"/>
+                    </a:ext>
+                  </a:extLst>
+                </a:hlinkClick>
+              </a:rPr>
+              <a:t>github.com/philippeabraxas-jpg/TBP-NETWORK</a:t>
+            </a:r>
+            <a:endParaRPr lang="en-US" sz="1200" dirty="0"/>
+          </a:p>
+        </p:txBody>
+      </p:sp>
+      <p:sp>
+        <p:nvSpPr>
+          <p:cNvPr id="11" name="Link Avidost"/>
+          <p:cNvSpPr/>
+          <p:nvPr/>
+        </p:nvSpPr>
+        <p:spPr>
+          <a:xfrm>
+            <a:off x="457200" y="3200400"/>
+            <a:ext cx="8229600" cy="868680"/>
+          </a:xfrm>
+          <a:prstGeom prst="roundRect">
+            <a:avLst>
+              <a:gd name="adj" fmla="val 8421"/>
+            </a:avLst>
+          </a:prstGeom>
+          <a:solidFill>
+            <a:schemeClr val="bg2"/>
+          </a:solidFill>
+          <a:ln w="6350">
+            <a:solidFill>
+              <a:schemeClr val="bg2"/>
+            </a:solidFill>
+            <a:prstDash val="solid"/>
+          </a:ln>
+        </p:spPr>
+      </p:sp>
+      <p:sp>
+        <p:nvSpPr>
+          <p:cNvPr id="12" name="Text 10"/>
+          <p:cNvSpPr txBox="1"/>
+          <p:nvPr/>
+        </p:nvSpPr>
+        <p:spPr>
+          <a:xfrm>
+            <a:off x="685800" y="3273552"/>
+            <a:ext cx="7772400" cy="320040"/>
+          </a:xfrm>
+          <a:prstGeom prst="rect">
+            <a:avLst/>
+          </a:prstGeom>
+          <a:noFill/>
+          <a:ln/>
+        </p:spPr>
+        <p:txBody>
+          <a:bodyPr wrap="square" lIns="0" tIns="0" rIns="0" bIns="0" rtlCol="0" anchor="ctr"/>
+          <a:lstStyle/>
+          <a:p>
+            <a:pPr indent="0" marL="0">
+              <a:buNone/>
+            </a:pPr>
+            <a:r>
+              <a:rPr lang="en-US" sz="1800" b="1" dirty="0">
+                <a:solidFill>
+                  <a:schemeClr val="tx1"/>
+                </a:solidFill>
+              </a:rPr>
+              <a:t>Avidost</a:t>
+            </a:r>
+            <a:endParaRPr lang="en-US" sz="1800" dirty="0"/>
+          </a:p>
+        </p:txBody>
+      </p:sp>
+      <p:sp>
+        <p:nvSpPr>
+          <p:cNvPr id="13" name="Text 11"/>
+          <p:cNvSpPr txBox="1"/>
+          <p:nvPr/>
+        </p:nvSpPr>
+        <p:spPr>
+          <a:xfrm>
+            <a:off x="685800" y="3584448"/>
+            <a:ext cx="7772400" cy="228600"/>
+          </a:xfrm>
+          <a:prstGeom prst="rect">
+            <a:avLst/>
+          </a:prstGeom>
+          <a:noFill/>
+          <a:ln/>
+        </p:spPr>
+        <p:txBody>
+          <a:bodyPr wrap="square" lIns="0" tIns="0" rIns="0" bIns="0" rtlCol="0" anchor="ctr"/>
+          <a:lstStyle/>
+          <a:p>
+            <a:pPr indent="0" marL="0">
+              <a:buNone/>
+            </a:pPr>
+            <a:r>
+              <a:rPr lang="en-US" sz="1200" dirty="0">
+                <a:solidFill>
+                  <a:schemeClr val="tx2"/>
+                </a:solidFill>
+              </a:rPr>
+              <a:t>The company behind INVARIAN</a:t>
+            </a:r>
+            <a:endParaRPr lang="en-US" sz="1200" dirty="0"/>
+          </a:p>
+        </p:txBody>
+      </p:sp>
+      <p:sp>
+        <p:nvSpPr>
+          <p:cNvPr id="14" name="Text 12">
+            <a:hlinkClick r:id="rId3" tooltip="Avidost"/>
+          </p:cNvPr>
+          <p:cNvSpPr txBox="1"/>
+          <p:nvPr/>
+        </p:nvSpPr>
+        <p:spPr>
+          <a:xfrm>
+            <a:off x="685800" y="3803904"/>
+            <a:ext cx="7772400" cy="228600"/>
+          </a:xfrm>
+          <a:prstGeom prst="rect">
+            <a:avLst/>
+          </a:prstGeom>
+          <a:noFill/>
+          <a:ln/>
+        </p:spPr>
+        <p:txBody>
+          <a:bodyPr wrap="square" lIns="0" tIns="0" rIns="0" bIns="0" rtlCol="0" anchor="ctr"/>
+          <a:lstStyle/>
+          <a:p>
+            <a:pPr indent="0" marL="0">
+              <a:buNone/>
+            </a:pPr>
+            <a:r>
+              <a:rPr lang="en-US" sz="1200" u="sng" dirty="0">
+                <a:solidFill>
+                  <a:schemeClr val="accent1"/>
+                </a:solidFill>
+                <a:hlinkClick r:id="rId3" invalidUrl="" action="" tgtFrame="" tooltip="Avidost" history="1" highlightClick="0" endSnd="0">
+                  <a:extLst>
+                    <a:ext uri="{A12FA001-AC4F-418D-AE19-62706E023703}">
+                      <ahyp:hlinkClr xmlns:ahyp="http://schemas.microsoft.com/office/drawing/2018/hyperlinkcolor" val="tx"/>
+                    </a:ext>
+                  </a:extLst>
+                </a:hlinkClick>
+              </a:rPr>
+              <a:t>avidost.fr</a:t>
+            </a:r>
+            <a:endParaRPr lang="en-US" sz="1200" dirty="0"/>
+          </a:p>
+        </p:txBody>
+      </p:sp>
+      <p:sp>
+        <p:nvSpPr>
+          <p:cNvPr id="25" name="Slide Number Placeholder 0"/>
+          <p:cNvSpPr>
+            <a:spLocks noGrp="1"/>
+          </p:cNvSpPr>
+          <p:nvPr>
+            <p:ph type="sldNum" sz="quarter" idx="4294967295"/>
+          </p:nvPr>
+        </p:nvSpPr>
+        <p:spPr>
+          <a:xfrm>
+            <a:off x="8229600" y="4754880"/>
+            <a:ext cx="457200" cy="274320"/>
+          </a:xfrm>
+          <a:prstGeom prst="rect">
+            <a:avLst/>
+          </a:prstGeom>
+          <a:extLst>
+            <a:ext uri="{C572A759-6A51-4108-AA02-DFA0A04FC94B}">
+              <ma14:wrappingTextBoxFlag xmlns:ma14="http://schemas.microsoft.com/office/mac/drawingml/2011/main" val="0"/>
+            </a:ext>
+          </a:extLst>
+        </p:spPr>
+        <p:txBody>
+          <a:bodyPr/>
+          <a:lstStyle>
+            <a:lvl1pPr>
+              <a:defRPr sz="1000">
+                <a:solidFill>
+                  <a:schemeClr val="accent4"/>
+                </a:solidFill>
+              </a:defRPr>
+            </a:lvl1pPr>
+          </a:lstStyle>
+          <a:p>
+            <a:pPr algn="r"/>
+            <a:fld id="{F7021451-1387-4CA6-816F-3879F97B5CBC}" type="slidenum">
+              <a:rPr b="0" lang="en-US"/>
+              <a:t>13</a:t>
+            </a:fld>
+            <a:endParaRPr lang="en-US"/>
+          </a:p>
+        </p:txBody>
+      </p:sp>
+    </p:spTree>
+  </p:cSld>
+  <p:clrMapOvr>
+    <a:masterClrMapping/>
+  </p:clrMapOvr>
+</p:sld>
+</file>
+
+<file path=ppt/slides/slide14.xml><?xml version="1.0" encoding="utf-8"?>
+<p:sld xmlns:a="http://schemas.openxmlformats.org/drawingml/2006/main" xmlns:r="http://schemas.openxmlformats.org/officeDocument/2006/relationships" xmlns:p="http://schemas.openxmlformats.org/presentationml/2006/main">
+  <p:cSld name="Slide 14">
     <p:spTree>
       <p:nvGrpSpPr>
         <p:cNvPr id="1" name=""/>
@@ -7017,7 +8421,7 @@
                   <a:schemeClr val="tx1"/>
                 </a:solidFill>
               </a:rPr>
-              <a:t>What is measured, dated and reproducible</a:t>
+              <a:t>Why this is the right design</a:t>
             </a:r>
             <a:endParaRPr lang="en-US" sz="3000" dirty="0"/>
           </a:p>
@@ -7025,18 +8429,18 @@
       </p:sp>
       <p:sp>
         <p:nvSpPr>
-          <p:cNvPr id="3" name="Stat card 240+"/>
+          <p:cNvPr id="3" name="Reason 1"/>
           <p:cNvSpPr/>
           <p:nvPr/>
         </p:nvSpPr>
         <p:spPr>
           <a:xfrm>
             <a:off x="457200" y="1188720"/>
-            <a:ext cx="1874520" cy="1508760"/>
+            <a:ext cx="8229600" cy="731520"/>
           </a:xfrm>
           <a:prstGeom prst="roundRect">
             <a:avLst>
-              <a:gd name="adj" fmla="val 4848"/>
+              <a:gd name="adj" fmla="val 10000"/>
             </a:avLst>
           </a:prstGeom>
           <a:solidFill>
@@ -7052,14 +8456,14 @@
       </p:sp>
       <p:sp>
         <p:nvSpPr>
-          <p:cNvPr id="4" name="Stat 240+"/>
+          <p:cNvPr id="4" name="Text 2"/>
           <p:cNvSpPr txBox="1"/>
           <p:nvPr/>
         </p:nvSpPr>
         <p:spPr>
           <a:xfrm>
-            <a:off x="594360" y="1325880"/>
-            <a:ext cx="1600200" cy="685800"/>
+            <a:off x="640080" y="1188720"/>
+            <a:ext cx="457200" cy="731520"/>
           </a:xfrm>
           <a:prstGeom prst="rect">
             <a:avLst/>
@@ -7075,14 +8479,14 @@
               <a:buNone/>
             </a:pPr>
             <a:r>
-              <a:rPr lang="en-US" sz="4000" b="1" dirty="0">
+              <a:rPr lang="en-US" sz="2800" b="1" dirty="0">
                 <a:solidFill>
                   <a:schemeClr val="accent1"/>
                 </a:solidFill>
               </a:rPr>
-              <a:t>240+</a:t>
-            </a:r>
-            <a:endParaRPr lang="en-US" sz="4000" dirty="0"/>
+              <a:t>1</a:t>
+            </a:r>
+            <a:endParaRPr lang="en-US" sz="2800" dirty="0"/>
           </a:p>
         </p:txBody>
       </p:sp>
@@ -7094,48 +8498,62 @@
         </p:nvSpPr>
         <p:spPr>
           <a:xfrm>
-            <a:off x="594360" y="2011680"/>
-            <a:ext cx="1600200" cy="640080"/>
-          </a:xfrm>
-          <a:prstGeom prst="rect">
-            <a:avLst/>
-          </a:prstGeom>
-          <a:noFill/>
-          <a:ln/>
-        </p:spPr>
-        <p:txBody>
-          <a:bodyPr wrap="square" lIns="0" tIns="0" rIns="0" bIns="0" rtlCol="0" anchor="t"/>
+            <a:off x="1188720" y="1188720"/>
+            <a:ext cx="7315200" cy="731520"/>
+          </a:xfrm>
+          <a:prstGeom prst="rect">
+            <a:avLst/>
+          </a:prstGeom>
+          <a:noFill/>
+          <a:ln/>
+        </p:spPr>
+        <p:txBody>
+          <a:bodyPr wrap="square" lIns="0" tIns="0" rIns="0" bIns="0" rtlCol="0" anchor="ctr"/>
           <a:lstStyle/>
           <a:p>
             <a:pPr indent="0" marL="0">
               <a:buNone/>
             </a:pPr>
             <a:r>
-              <a:rPr lang="en-US" sz="1400" dirty="0">
+              <a:rPr lang="en-US" sz="1600" b="1" dirty="0">
+                <a:solidFill>
+                  <a:schemeClr val="tx1"/>
+                </a:solidFill>
+              </a:rPr>
+              <a:t>A model is probabilistic</a:t>
+            </a:r>
+            <a:endParaRPr lang="en-US" sz="1600" dirty="0"/>
+          </a:p>
+          <a:p>
+            <a:pPr indent="0" marL="0">
+              <a:buNone/>
+            </a:pPr>
+            <a:r>
+              <a:rPr lang="en-US" sz="1300" dirty="0">
                 <a:solidFill>
                   <a:schemeClr val="tx2"/>
                 </a:solidFill>
               </a:rPr>
-              <a:t>automated end-to-end checks on the real programs</a:t>
-            </a:r>
-            <a:endParaRPr lang="en-US" sz="1400" dirty="0"/>
-          </a:p>
-        </p:txBody>
-      </p:sp>
-      <p:sp>
-        <p:nvSpPr>
-          <p:cNvPr id="6" name="Stat card 22"/>
+              <a:t>You cannot know in advance what it will write, so security cannot depend on its text.</a:t>
+            </a:r>
+            <a:endParaRPr lang="en-US" sz="1600" dirty="0"/>
+          </a:p>
+        </p:txBody>
+      </p:sp>
+      <p:sp>
+        <p:nvSpPr>
+          <p:cNvPr id="6" name="Reason 2"/>
           <p:cNvSpPr/>
           <p:nvPr/>
         </p:nvSpPr>
         <p:spPr>
           <a:xfrm>
-            <a:off x="2423160" y="1188720"/>
-            <a:ext cx="1874520" cy="1508760"/>
+            <a:off x="457200" y="2057400"/>
+            <a:ext cx="8229600" cy="731520"/>
           </a:xfrm>
           <a:prstGeom prst="roundRect">
             <a:avLst>
-              <a:gd name="adj" fmla="val 4848"/>
+              <a:gd name="adj" fmla="val 10000"/>
             </a:avLst>
           </a:prstGeom>
           <a:solidFill>
@@ -7151,14 +8569,14 @@
       </p:sp>
       <p:sp>
         <p:nvSpPr>
-          <p:cNvPr id="7" name="Stat 22"/>
+          <p:cNvPr id="7" name="Text 5"/>
           <p:cNvSpPr txBox="1"/>
           <p:nvPr/>
         </p:nvSpPr>
         <p:spPr>
           <a:xfrm>
-            <a:off x="2560320" y="1325880"/>
-            <a:ext cx="1600200" cy="685800"/>
+            <a:off x="640080" y="2057400"/>
+            <a:ext cx="457200" cy="731520"/>
           </a:xfrm>
           <a:prstGeom prst="rect">
             <a:avLst/>
@@ -7174,14 +8592,14 @@
               <a:buNone/>
             </a:pPr>
             <a:r>
-              <a:rPr lang="en-US" sz="4000" b="1" dirty="0">
+              <a:rPr lang="en-US" sz="2800" b="1" dirty="0">
                 <a:solidFill>
                   <a:schemeClr val="accent1"/>
                 </a:solidFill>
               </a:rPr>
-              <a:t>22</a:t>
-            </a:r>
-            <a:endParaRPr lang="en-US" sz="4000" dirty="0"/>
+              <a:t>2</a:t>
+            </a:r>
+            <a:endParaRPr lang="en-US" sz="2800" dirty="0"/>
           </a:p>
         </p:txBody>
       </p:sp>
@@ -7193,48 +8611,62 @@
         </p:nvSpPr>
         <p:spPr>
           <a:xfrm>
-            <a:off x="2560320" y="2011680"/>
-            <a:ext cx="1600200" cy="640080"/>
-          </a:xfrm>
-          <a:prstGeom prst="rect">
-            <a:avLst/>
-          </a:prstGeom>
-          <a:noFill/>
-          <a:ln/>
-        </p:spPr>
-        <p:txBody>
-          <a:bodyPr wrap="square" lIns="0" tIns="0" rIns="0" bIns="0" rtlCol="0" anchor="t"/>
+            <a:off x="1188720" y="2057400"/>
+            <a:ext cx="7315200" cy="731520"/>
+          </a:xfrm>
+          <a:prstGeom prst="rect">
+            <a:avLst/>
+          </a:prstGeom>
+          <a:noFill/>
+          <a:ln/>
+        </p:spPr>
+        <p:txBody>
+          <a:bodyPr wrap="square" lIns="0" tIns="0" rIns="0" bIns="0" rtlCol="0" anchor="ctr"/>
           <a:lstStyle/>
           <a:p>
             <a:pPr indent="0" marL="0">
               <a:buNone/>
             </a:pPr>
             <a:r>
-              <a:rPr lang="en-US" sz="1400" dirty="0">
+              <a:rPr lang="en-US" sz="1600" b="1" dirty="0">
+                <a:solidFill>
+                  <a:schemeClr val="tx1"/>
+                </a:solidFill>
+              </a:rPr>
+              <a:t>An action is checkable</a:t>
+            </a:r>
+            <a:endParaRPr lang="en-US" sz="1600" dirty="0"/>
+          </a:p>
+          <a:p>
+            <a:pPr indent="0" marL="0">
+              <a:buNone/>
+            </a:pPr>
+            <a:r>
+              <a:rPr lang="en-US" sz="1300" dirty="0">
                 <a:solidFill>
                   <a:schemeClr val="tx2"/>
                 </a:solidFill>
               </a:rPr>
-              <a:t>red-team findings; no unmitigated fraud flaw</a:t>
-            </a:r>
-            <a:endParaRPr lang="en-US" sz="1400" dirty="0"/>
-          </a:p>
-        </p:txBody>
-      </p:sp>
-      <p:sp>
-        <p:nvSpPr>
-          <p:cNvPr id="9" name="Stat card ≈ 3 ms"/>
+              <a:t>A deterministic engine judges the requested action before it runs: same request, same verdict.</a:t>
+            </a:r>
+            <a:endParaRPr lang="en-US" sz="1600" dirty="0"/>
+          </a:p>
+        </p:txBody>
+      </p:sp>
+      <p:sp>
+        <p:nvSpPr>
+          <p:cNvPr id="9" name="Reason 3"/>
           <p:cNvSpPr/>
           <p:nvPr/>
         </p:nvSpPr>
         <p:spPr>
           <a:xfrm>
-            <a:off x="4389120" y="1188720"/>
-            <a:ext cx="1874520" cy="1508760"/>
+            <a:off x="457200" y="2926080"/>
+            <a:ext cx="8229600" cy="731520"/>
           </a:xfrm>
           <a:prstGeom prst="roundRect">
             <a:avLst>
-              <a:gd name="adj" fmla="val 4848"/>
+              <a:gd name="adj" fmla="val 10000"/>
             </a:avLst>
           </a:prstGeom>
           <a:solidFill>
@@ -7250,14 +8682,14 @@
       </p:sp>
       <p:sp>
         <p:nvSpPr>
-          <p:cNvPr id="10" name="Stat ≈ 3 ms"/>
+          <p:cNvPr id="10" name="Text 8"/>
           <p:cNvSpPr txBox="1"/>
           <p:nvPr/>
         </p:nvSpPr>
         <p:spPr>
           <a:xfrm>
-            <a:off x="4526280" y="1325880"/>
-            <a:ext cx="1600200" cy="685800"/>
+            <a:off x="640080" y="2926080"/>
+            <a:ext cx="457200" cy="731520"/>
           </a:xfrm>
           <a:prstGeom prst="rect">
             <a:avLst/>
@@ -7273,14 +8705,14 @@
               <a:buNone/>
             </a:pPr>
             <a:r>
-              <a:rPr lang="en-US" sz="4000" b="1" dirty="0">
+              <a:rPr lang="en-US" sz="2800" b="1" dirty="0">
                 <a:solidFill>
                   <a:schemeClr val="accent1"/>
                 </a:solidFill>
               </a:rPr>
-              <a:t>≈ 3 ms</a:t>
-            </a:r>
-            <a:endParaRPr lang="en-US" sz="4000" dirty="0"/>
+              <a:t>3</a:t>
+            </a:r>
+            <a:endParaRPr lang="en-US" sz="2800" dirty="0"/>
           </a:p>
         </p:txBody>
       </p:sp>
@@ -7292,8 +8724,58 @@
         </p:nvSpPr>
         <p:spPr>
           <a:xfrm>
-            <a:off x="4526280" y="2011680"/>
-            <a:ext cx="1600200" cy="640080"/>
+            <a:off x="1188720" y="2926080"/>
+            <a:ext cx="7315200" cy="731520"/>
+          </a:xfrm>
+          <a:prstGeom prst="rect">
+            <a:avLst/>
+          </a:prstGeom>
+          <a:noFill/>
+          <a:ln/>
+        </p:spPr>
+        <p:txBody>
+          <a:bodyPr wrap="square" lIns="0" tIns="0" rIns="0" bIns="0" rtlCol="0" anchor="ctr"/>
+          <a:lstStyle/>
+          <a:p>
+            <a:pPr indent="0" marL="0">
+              <a:buNone/>
+            </a:pPr>
+            <a:r>
+              <a:rPr lang="en-US" sz="1600" b="1" dirty="0">
+                <a:solidFill>
+                  <a:schemeClr val="tx1"/>
+                </a:solidFill>
+              </a:rPr>
+              <a:t>Evidence must be verifiable</a:t>
+            </a:r>
+            <a:endParaRPr lang="en-US" sz="1600" dirty="0"/>
+          </a:p>
+          <a:p>
+            <a:pPr indent="0" marL="0">
+              <a:buNone/>
+            </a:pPr>
+            <a:r>
+              <a:rPr lang="en-US" sz="1300" dirty="0">
+                <a:solidFill>
+                  <a:schemeClr val="tx2"/>
+                </a:solidFill>
+              </a:rPr>
+              <a:t>Signed, timestamped, chained records let an auditor verify without trusting the operator.</a:t>
+            </a:r>
+            <a:endParaRPr lang="en-US" sz="1600" dirty="0"/>
+          </a:p>
+        </p:txBody>
+      </p:sp>
+      <p:sp>
+        <p:nvSpPr>
+          <p:cNvPr id="12" name="Text 10"/>
+          <p:cNvSpPr txBox="1"/>
+          <p:nvPr/>
+        </p:nvSpPr>
+        <p:spPr>
+          <a:xfrm>
+            <a:off x="457200" y="3886200"/>
+            <a:ext cx="8229600" cy="731520"/>
           </a:xfrm>
           <a:prstGeom prst="rect">
             <a:avLst/>
@@ -7309,225 +8791,14 @@
               <a:buNone/>
             </a:pPr>
             <a:r>
-              <a:rPr lang="en-US" sz="1400" dirty="0">
-                <a:solidFill>
-                  <a:schemeClr val="tx2"/>
-                </a:solidFill>
-              </a:rPr>
-              <a:t>decision latency p99, dev machine</a:t>
-            </a:r>
-            <a:endParaRPr lang="en-US" sz="1400" dirty="0"/>
-          </a:p>
-        </p:txBody>
-      </p:sp>
-      <p:sp>
-        <p:nvSpPr>
-          <p:cNvPr id="12" name="Stat card 21"/>
-          <p:cNvSpPr/>
-          <p:nvPr/>
-        </p:nvSpPr>
-        <p:spPr>
-          <a:xfrm>
-            <a:off x="6355080" y="1188720"/>
-            <a:ext cx="2331720" cy="1508760"/>
-          </a:xfrm>
-          <a:prstGeom prst="roundRect">
-            <a:avLst>
-              <a:gd name="adj" fmla="val 4848"/>
-            </a:avLst>
-          </a:prstGeom>
-          <a:solidFill>
-            <a:schemeClr val="bg2"/>
-          </a:solidFill>
-          <a:ln w="6350">
-            <a:solidFill>
-              <a:schemeClr val="bg2"/>
-            </a:solidFill>
-            <a:prstDash val="solid"/>
-          </a:ln>
-        </p:spPr>
-      </p:sp>
-      <p:sp>
-        <p:nvSpPr>
-          <p:cNvPr id="13" name="Stat 21"/>
-          <p:cNvSpPr txBox="1"/>
-          <p:nvPr/>
-        </p:nvSpPr>
-        <p:spPr>
-          <a:xfrm>
-            <a:off x="6492240" y="1325880"/>
-            <a:ext cx="2057400" cy="685800"/>
-          </a:xfrm>
-          <a:prstGeom prst="rect">
-            <a:avLst/>
-          </a:prstGeom>
-          <a:noFill/>
-          <a:ln/>
-        </p:spPr>
-        <p:txBody>
-          <a:bodyPr wrap="square" lIns="0" tIns="0" rIns="0" bIns="0" rtlCol="0" anchor="ctr"/>
-          <a:lstStyle/>
-          <a:p>
-            <a:pPr indent="0" marL="0">
-              <a:buNone/>
-            </a:pPr>
-            <a:r>
-              <a:rPr lang="en-US" sz="4000" b="1" dirty="0">
-                <a:solidFill>
-                  <a:schemeClr val="accent1"/>
-                </a:solidFill>
-              </a:rPr>
-              <a:t>21</a:t>
-            </a:r>
-            <a:endParaRPr lang="en-US" sz="4000" dirty="0"/>
-          </a:p>
-        </p:txBody>
-      </p:sp>
-      <p:sp>
-        <p:nvSpPr>
-          <p:cNvPr id="14" name="Text 12"/>
-          <p:cNvSpPr txBox="1"/>
-          <p:nvPr/>
-        </p:nvSpPr>
-        <p:spPr>
-          <a:xfrm>
-            <a:off x="6492240" y="2011680"/>
-            <a:ext cx="2057400" cy="640080"/>
-          </a:xfrm>
-          <a:prstGeom prst="rect">
-            <a:avLst/>
-          </a:prstGeom>
-          <a:noFill/>
-          <a:ln/>
-        </p:spPr>
-        <p:txBody>
-          <a:bodyPr wrap="square" lIns="0" tIns="0" rIns="0" bIns="0" rtlCol="0" anchor="t"/>
-          <a:lstStyle/>
-          <a:p>
-            <a:pPr indent="0" marL="0">
-              <a:buNone/>
-            </a:pPr>
-            <a:r>
-              <a:rPr lang="en-US" sz="1400" dirty="0">
-                <a:solidFill>
-                  <a:schemeClr val="tx2"/>
-                </a:solidFill>
-              </a:rPr>
-              <a:t>compliance mappings, read control by control</a:t>
-            </a:r>
-            <a:endParaRPr lang="en-US" sz="1400" dirty="0"/>
-          </a:p>
-        </p:txBody>
-      </p:sp>
-      <p:sp>
-        <p:nvSpPr>
-          <p:cNvPr id="15" name="Text 13"/>
-          <p:cNvSpPr txBox="1"/>
-          <p:nvPr/>
-        </p:nvSpPr>
-        <p:spPr>
-          <a:xfrm>
-            <a:off x="457200" y="2834640"/>
-            <a:ext cx="8229600" cy="1371600"/>
-          </a:xfrm>
-          <a:prstGeom prst="rect">
-            <a:avLst/>
-          </a:prstGeom>
-          <a:noFill/>
-          <a:ln/>
-        </p:spPr>
-        <p:txBody>
-          <a:bodyPr wrap="square" lIns="0" tIns="0" rIns="0" bIns="0" rtlCol="0" anchor="t"/>
-          <a:lstStyle/>
-          <a:p>
-            <a:pPr marL="342900" indent="-342900">
-              <a:spcAft>
-                <a:spcPts val="600"/>
-              </a:spcAft>
-              <a:buSzPct val="100000"/>
-              <a:buChar char="•"/>
-            </a:pPr>
-            <a:r>
-              <a:rPr lang="en-US" sz="1400" dirty="0">
+              <a:rPr lang="en-US" sz="1600" b="1" dirty="0">
                 <a:solidFill>
                   <a:schemeClr val="tx1"/>
                 </a:solidFill>
               </a:rPr>
-              <a:t>Selftest runs on every code change (CI); fixes are mutation-tested.</a:t>
-            </a:r>
-            <a:endParaRPr lang="en-US" sz="1400" dirty="0"/>
-          </a:p>
-          <a:p>
-            <a:pPr marL="342900" indent="-342900">
-              <a:spcAft>
-                <a:spcPts val="600"/>
-              </a:spcAft>
-              <a:buSzPct val="100000"/>
-              <a:buChar char="•"/>
-            </a:pPr>
-            <a:r>
-              <a:rPr lang="en-US" sz="1400" dirty="0">
-                <a:solidFill>
-                  <a:schemeClr val="tx1"/>
-                </a:solidFill>
-              </a:rPr>
-              <a:t>Red team 1 Oct 2026: 5 passes, 25 files, static analysis. The high-severity finding is fixed and covered.</a:t>
-            </a:r>
-            <a:endParaRPr lang="en-US" sz="1400" dirty="0"/>
-          </a:p>
-          <a:p>
-            <a:pPr marL="342900" indent="-342900">
-              <a:spcAft>
-                <a:spcPts val="600"/>
-              </a:spcAft>
-              <a:buSzPct val="100000"/>
-              <a:buChar char="•"/>
-            </a:pPr>
-            <a:r>
-              <a:rPr lang="en-US" sz="1400" dirty="0">
-                <a:solidFill>
-                  <a:schemeClr val="tx1"/>
-                </a:solidFill>
-              </a:rPr>
-              <a:t>Latency measured on a 4-CPU development VM (2 Oct 2026): not a production result.</a:t>
-            </a:r>
-            <a:endParaRPr lang="en-US" sz="1400" dirty="0"/>
-          </a:p>
-        </p:txBody>
-      </p:sp>
-      <p:sp>
-        <p:nvSpPr>
-          <p:cNvPr id="16" name="Text 14"/>
-          <p:cNvSpPr txBox="1"/>
-          <p:nvPr/>
-        </p:nvSpPr>
-        <p:spPr>
-          <a:xfrm>
-            <a:off x="457200" y="4343400"/>
-            <a:ext cx="7680960" cy="274320"/>
-          </a:xfrm>
-          <a:prstGeom prst="rect">
-            <a:avLst/>
-          </a:prstGeom>
-          <a:noFill/>
-          <a:ln/>
-        </p:spPr>
-        <p:txBody>
-          <a:bodyPr wrap="square" lIns="0" tIns="0" rIns="0" bIns="0" rtlCol="0" anchor="ctr"/>
-          <a:lstStyle/>
-          <a:p>
-            <a:pPr indent="0" marL="0">
-              <a:buNone/>
-            </a:pPr>
-            <a:r>
-              <a:rPr lang="en-US" sz="1100" dirty="0">
-                <a:solidFill>
-                  <a:schemeClr val="accent4"/>
-                </a:solidFill>
-              </a:rPr>
-              <a:t>Source: github.com/philippeabraxas-jpg/TBP-NETWORK (tests/, docs/audits/, tbp-compliance/)</a:t>
-            </a:r>
-            <a:endParaRPr lang="en-US" sz="1100" dirty="0"/>
+              <a:t>TBP turns an unsolvable problem, preventing every LLM error, into a solvable one: bounded, traceable, attributable.</a:t>
+            </a:r>
+            <a:endParaRPr lang="en-US" sz="1600" dirty="0"/>
           </a:p>
         </p:txBody>
       </p:sp>
@@ -7633,7 +8904,7 @@
                   <a:schemeClr val="tx1"/>
                 </a:solidFill>
               </a:rPr>
-              <a:t>EU AI Act: a mechanism, not a procedure</a:t>
+              <a:t>What is measured, dated and reproducible</a:t>
             </a:r>
             <a:endParaRPr lang="en-US" sz="3000" dirty="0"/>
           </a:p>
@@ -7641,18 +8912,18 @@
       </p:sp>
       <p:sp>
         <p:nvSpPr>
-          <p:cNvPr id="3" name="Row Art. 12"/>
+          <p:cNvPr id="3" name="Stat card 240+"/>
           <p:cNvSpPr/>
           <p:nvPr/>
         </p:nvSpPr>
         <p:spPr>
           <a:xfrm>
-            <a:off x="457200" y="1234440"/>
-            <a:ext cx="8229600" cy="777240"/>
+            <a:off x="457200" y="1188720"/>
+            <a:ext cx="1874520" cy="1508760"/>
           </a:xfrm>
           <a:prstGeom prst="roundRect">
             <a:avLst>
-              <a:gd name="adj" fmla="val 9412"/>
+              <a:gd name="adj" fmla="val 4848"/>
             </a:avLst>
           </a:prstGeom>
           <a:solidFill>
@@ -7668,14 +8939,14 @@
       </p:sp>
       <p:sp>
         <p:nvSpPr>
-          <p:cNvPr id="4" name="Text 2"/>
+          <p:cNvPr id="4" name="Stat 240+"/>
           <p:cNvSpPr txBox="1"/>
           <p:nvPr/>
         </p:nvSpPr>
         <p:spPr>
           <a:xfrm>
-            <a:off x="640080" y="1234440"/>
-            <a:ext cx="1005840" cy="777240"/>
+            <a:off x="594360" y="1325880"/>
+            <a:ext cx="1600200" cy="685800"/>
           </a:xfrm>
           <a:prstGeom prst="rect">
             <a:avLst/>
@@ -7691,14 +8962,14 @@
               <a:buNone/>
             </a:pPr>
             <a:r>
-              <a:rPr lang="en-US" sz="2000" b="1" dirty="0">
+              <a:rPr lang="en-US" sz="4000" b="1" dirty="0">
                 <a:solidFill>
                   <a:schemeClr val="accent1"/>
                 </a:solidFill>
               </a:rPr>
-              <a:t>Art. 12</a:t>
-            </a:r>
-            <a:endParaRPr lang="en-US" sz="2000" dirty="0"/>
+              <a:t>240+</a:t>
+            </a:r>
+            <a:endParaRPr lang="en-US" sz="4000" dirty="0"/>
           </a:p>
         </p:txBody>
       </p:sp>
@@ -7710,98 +8981,48 @@
         </p:nvSpPr>
         <p:spPr>
           <a:xfrm>
-            <a:off x="1737360" y="1234440"/>
-            <a:ext cx="5120640" cy="777240"/>
-          </a:xfrm>
-          <a:prstGeom prst="rect">
-            <a:avLst/>
-          </a:prstGeom>
-          <a:noFill/>
-          <a:ln/>
-        </p:spPr>
-        <p:txBody>
-          <a:bodyPr wrap="square" lIns="0" tIns="0" rIns="0" bIns="0" rtlCol="0" anchor="ctr"/>
+            <a:off x="594360" y="2011680"/>
+            <a:ext cx="1600200" cy="640080"/>
+          </a:xfrm>
+          <a:prstGeom prst="rect">
+            <a:avLst/>
+          </a:prstGeom>
+          <a:noFill/>
+          <a:ln/>
+        </p:spPr>
+        <p:txBody>
+          <a:bodyPr wrap="square" lIns="0" tIns="0" rIns="0" bIns="0" rtlCol="0" anchor="t"/>
           <a:lstStyle/>
           <a:p>
             <a:pPr indent="0" marL="0">
               <a:buNone/>
             </a:pPr>
             <a:r>
-              <a:rPr lang="en-US" sz="1500" b="1" dirty="0">
-                <a:solidFill>
-                  <a:schemeClr val="tx1"/>
-                </a:solidFill>
-              </a:rPr>
-              <a:t>Record-keeping</a:t>
-            </a:r>
-            <a:endParaRPr lang="en-US" sz="1500" dirty="0"/>
-          </a:p>
-          <a:p>
-            <a:pPr indent="0" marL="0">
-              <a:buNone/>
-            </a:pPr>
-            <a:r>
-              <a:rPr lang="en-US" sz="1300" dirty="0">
+              <a:rPr lang="en-US" sz="1400" dirty="0">
                 <a:solidFill>
                   <a:schemeClr val="tx2"/>
                 </a:solidFill>
               </a:rPr>
-              <a:t>Merkle chain, hash-only records, hardware signature</a:t>
-            </a:r>
-            <a:endParaRPr lang="en-US" sz="1500" dirty="0"/>
-          </a:p>
-        </p:txBody>
-      </p:sp>
-      <p:sp>
-        <p:nvSpPr>
-          <p:cNvPr id="6" name="Text 4"/>
-          <p:cNvSpPr txBox="1"/>
-          <p:nvPr/>
-        </p:nvSpPr>
-        <p:spPr>
-          <a:xfrm>
-            <a:off x="7132320" y="1234440"/>
-            <a:ext cx="1371600" cy="777240"/>
-          </a:xfrm>
-          <a:prstGeom prst="rect">
-            <a:avLst/>
-          </a:prstGeom>
-          <a:noFill/>
-          <a:ln/>
-        </p:spPr>
-        <p:txBody>
-          <a:bodyPr wrap="square" lIns="0" tIns="0" rIns="0" bIns="0" rtlCol="0" anchor="ctr"/>
-          <a:lstStyle/>
-          <a:p>
-            <a:pPr algn="r" indent="0" marL="0">
-              <a:buNone/>
-            </a:pPr>
-            <a:r>
-              <a:rPr lang="en-US" sz="1500" b="1" dirty="0">
-                <a:solidFill>
-                  <a:schemeClr val="accent2"/>
-                </a:solidFill>
-              </a:rPr>
-              <a:t>Covered</a:t>
-            </a:r>
-            <a:endParaRPr lang="en-US" sz="1500" dirty="0"/>
-          </a:p>
-        </p:txBody>
-      </p:sp>
-      <p:sp>
-        <p:nvSpPr>
-          <p:cNvPr id="7" name="Row Art. 14"/>
+              <a:t>automated end-to-end checks on the real programs</a:t>
+            </a:r>
+            <a:endParaRPr lang="en-US" sz="1400" dirty="0"/>
+          </a:p>
+        </p:txBody>
+      </p:sp>
+      <p:sp>
+        <p:nvSpPr>
+          <p:cNvPr id="6" name="Stat card 22"/>
           <p:cNvSpPr/>
           <p:nvPr/>
         </p:nvSpPr>
         <p:spPr>
           <a:xfrm>
-            <a:off x="457200" y="2148840"/>
-            <a:ext cx="8229600" cy="777240"/>
+            <a:off x="2423160" y="1188720"/>
+            <a:ext cx="1874520" cy="1508760"/>
           </a:xfrm>
           <a:prstGeom prst="roundRect">
             <a:avLst>
-              <a:gd name="adj" fmla="val 9412"/>
+              <a:gd name="adj" fmla="val 4848"/>
             </a:avLst>
           </a:prstGeom>
           <a:solidFill>
@@ -7817,140 +9038,90 @@
       </p:sp>
       <p:sp>
         <p:nvSpPr>
+          <p:cNvPr id="7" name="Stat 22"/>
+          <p:cNvSpPr txBox="1"/>
+          <p:nvPr/>
+        </p:nvSpPr>
+        <p:spPr>
+          <a:xfrm>
+            <a:off x="2560320" y="1325880"/>
+            <a:ext cx="1600200" cy="685800"/>
+          </a:xfrm>
+          <a:prstGeom prst="rect">
+            <a:avLst/>
+          </a:prstGeom>
+          <a:noFill/>
+          <a:ln/>
+        </p:spPr>
+        <p:txBody>
+          <a:bodyPr wrap="square" lIns="0" tIns="0" rIns="0" bIns="0" rtlCol="0" anchor="ctr"/>
+          <a:lstStyle/>
+          <a:p>
+            <a:pPr indent="0" marL="0">
+              <a:buNone/>
+            </a:pPr>
+            <a:r>
+              <a:rPr lang="en-US" sz="4000" b="1" dirty="0">
+                <a:solidFill>
+                  <a:schemeClr val="accent1"/>
+                </a:solidFill>
+              </a:rPr>
+              <a:t>22</a:t>
+            </a:r>
+            <a:endParaRPr lang="en-US" sz="4000" dirty="0"/>
+          </a:p>
+        </p:txBody>
+      </p:sp>
+      <p:sp>
+        <p:nvSpPr>
           <p:cNvPr id="8" name="Text 6"/>
           <p:cNvSpPr txBox="1"/>
           <p:nvPr/>
         </p:nvSpPr>
         <p:spPr>
           <a:xfrm>
-            <a:off x="640080" y="2148840"/>
-            <a:ext cx="1005840" cy="777240"/>
-          </a:xfrm>
-          <a:prstGeom prst="rect">
-            <a:avLst/>
-          </a:prstGeom>
-          <a:noFill/>
-          <a:ln/>
-        </p:spPr>
-        <p:txBody>
-          <a:bodyPr wrap="square" lIns="0" tIns="0" rIns="0" bIns="0" rtlCol="0" anchor="ctr"/>
+            <a:off x="2560320" y="2011680"/>
+            <a:ext cx="1600200" cy="640080"/>
+          </a:xfrm>
+          <a:prstGeom prst="rect">
+            <a:avLst/>
+          </a:prstGeom>
+          <a:noFill/>
+          <a:ln/>
+        </p:spPr>
+        <p:txBody>
+          <a:bodyPr wrap="square" lIns="0" tIns="0" rIns="0" bIns="0" rtlCol="0" anchor="t"/>
           <a:lstStyle/>
           <a:p>
             <a:pPr indent="0" marL="0">
               <a:buNone/>
             </a:pPr>
             <a:r>
-              <a:rPr lang="en-US" sz="2000" b="1" dirty="0">
-                <a:solidFill>
-                  <a:schemeClr val="accent1"/>
-                </a:solidFill>
-              </a:rPr>
-              <a:t>Art. 14</a:t>
-            </a:r>
-            <a:endParaRPr lang="en-US" sz="2000" dirty="0"/>
-          </a:p>
-        </p:txBody>
-      </p:sp>
-      <p:sp>
-        <p:nvSpPr>
-          <p:cNvPr id="9" name="Text 7"/>
-          <p:cNvSpPr txBox="1"/>
-          <p:nvPr/>
-        </p:nvSpPr>
-        <p:spPr>
-          <a:xfrm>
-            <a:off x="1737360" y="2148840"/>
-            <a:ext cx="5120640" cy="777240"/>
-          </a:xfrm>
-          <a:prstGeom prst="rect">
-            <a:avLst/>
-          </a:prstGeom>
-          <a:noFill/>
-          <a:ln/>
-        </p:spPr>
-        <p:txBody>
-          <a:bodyPr wrap="square" lIns="0" tIns="0" rIns="0" bIns="0" rtlCol="0" anchor="ctr"/>
-          <a:lstStyle/>
-          <a:p>
-            <a:pPr indent="0" marL="0">
-              <a:buNone/>
-            </a:pPr>
-            <a:r>
-              <a:rPr lang="en-US" sz="1500" b="1" dirty="0">
-                <a:solidFill>
-                  <a:schemeClr val="tx1"/>
-                </a:solidFill>
-              </a:rPr>
-              <a:t>Human oversight</a:t>
-            </a:r>
-            <a:endParaRPr lang="en-US" sz="1500" dirty="0"/>
-          </a:p>
-          <a:p>
-            <a:pPr indent="0" marL="0">
-              <a:buNone/>
-            </a:pPr>
-            <a:r>
-              <a:rPr lang="en-US" sz="1300" dirty="0">
+              <a:rPr lang="en-US" sz="1400" dirty="0">
                 <a:solidFill>
                   <a:schemeClr val="tx2"/>
                 </a:solidFill>
               </a:rPr>
-              <a:t>k-of-n co-signature before an irreversible action</a:t>
-            </a:r>
-            <a:endParaRPr lang="en-US" sz="1500" dirty="0"/>
-          </a:p>
-        </p:txBody>
-      </p:sp>
-      <p:sp>
-        <p:nvSpPr>
-          <p:cNvPr id="10" name="Text 8"/>
-          <p:cNvSpPr txBox="1"/>
-          <p:nvPr/>
-        </p:nvSpPr>
-        <p:spPr>
-          <a:xfrm>
-            <a:off x="7132320" y="2148840"/>
-            <a:ext cx="1371600" cy="777240"/>
-          </a:xfrm>
-          <a:prstGeom prst="rect">
-            <a:avLst/>
-          </a:prstGeom>
-          <a:noFill/>
-          <a:ln/>
-        </p:spPr>
-        <p:txBody>
-          <a:bodyPr wrap="square" lIns="0" tIns="0" rIns="0" bIns="0" rtlCol="0" anchor="ctr"/>
-          <a:lstStyle/>
-          <a:p>
-            <a:pPr algn="r" indent="0" marL="0">
-              <a:buNone/>
-            </a:pPr>
-            <a:r>
-              <a:rPr lang="en-US" sz="1500" b="1" dirty="0">
-                <a:solidFill>
-                  <a:schemeClr val="accent2"/>
-                </a:solidFill>
-              </a:rPr>
-              <a:t>Covered</a:t>
-            </a:r>
-            <a:endParaRPr lang="en-US" sz="1500" dirty="0"/>
-          </a:p>
-        </p:txBody>
-      </p:sp>
-      <p:sp>
-        <p:nvSpPr>
-          <p:cNvPr id="11" name="Row Art. 15"/>
+              <a:t>red-team findings; no unmitigated fraud flaw</a:t>
+            </a:r>
+            <a:endParaRPr lang="en-US" sz="1400" dirty="0"/>
+          </a:p>
+        </p:txBody>
+      </p:sp>
+      <p:sp>
+        <p:nvSpPr>
+          <p:cNvPr id="9" name="Stat card ≈ 3 ms"/>
           <p:cNvSpPr/>
           <p:nvPr/>
         </p:nvSpPr>
         <p:spPr>
           <a:xfrm>
-            <a:off x="457200" y="3063240"/>
-            <a:ext cx="8229600" cy="777240"/>
+            <a:off x="4389120" y="1188720"/>
+            <a:ext cx="1874520" cy="1508760"/>
           </a:xfrm>
           <a:prstGeom prst="roundRect">
             <a:avLst>
-              <a:gd name="adj" fmla="val 9412"/>
+              <a:gd name="adj" fmla="val 4848"/>
             </a:avLst>
           </a:prstGeom>
           <a:solidFill>
@@ -7966,14 +9137,14 @@
       </p:sp>
       <p:sp>
         <p:nvSpPr>
-          <p:cNvPr id="12" name="Text 10"/>
+          <p:cNvPr id="10" name="Stat ≈ 3 ms"/>
           <p:cNvSpPr txBox="1"/>
           <p:nvPr/>
         </p:nvSpPr>
         <p:spPr>
           <a:xfrm>
-            <a:off x="640080" y="3063240"/>
-            <a:ext cx="1005840" cy="777240"/>
+            <a:off x="4526280" y="1325880"/>
+            <a:ext cx="1600200" cy="685800"/>
           </a:xfrm>
           <a:prstGeom prst="rect">
             <a:avLst/>
@@ -7989,27 +9160,90 @@
               <a:buNone/>
             </a:pPr>
             <a:r>
-              <a:rPr lang="en-US" sz="2000" b="1" dirty="0">
+              <a:rPr lang="en-US" sz="4000" b="1" dirty="0">
                 <a:solidFill>
                   <a:schemeClr val="accent1"/>
                 </a:solidFill>
               </a:rPr>
-              <a:t>Art. 15</a:t>
-            </a:r>
-            <a:endParaRPr lang="en-US" sz="2000" dirty="0"/>
-          </a:p>
-        </p:txBody>
-      </p:sp>
-      <p:sp>
-        <p:nvSpPr>
-          <p:cNvPr id="13" name="Text 11"/>
+              <a:t>≈ 3 ms</a:t>
+            </a:r>
+            <a:endParaRPr lang="en-US" sz="4000" dirty="0"/>
+          </a:p>
+        </p:txBody>
+      </p:sp>
+      <p:sp>
+        <p:nvSpPr>
+          <p:cNvPr id="11" name="Text 9"/>
           <p:cNvSpPr txBox="1"/>
           <p:nvPr/>
         </p:nvSpPr>
         <p:spPr>
           <a:xfrm>
-            <a:off x="1737360" y="3063240"/>
-            <a:ext cx="5120640" cy="777240"/>
+            <a:off x="4526280" y="2011680"/>
+            <a:ext cx="1600200" cy="640080"/>
+          </a:xfrm>
+          <a:prstGeom prst="rect">
+            <a:avLst/>
+          </a:prstGeom>
+          <a:noFill/>
+          <a:ln/>
+        </p:spPr>
+        <p:txBody>
+          <a:bodyPr wrap="square" lIns="0" tIns="0" rIns="0" bIns="0" rtlCol="0" anchor="t"/>
+          <a:lstStyle/>
+          <a:p>
+            <a:pPr indent="0" marL="0">
+              <a:buNone/>
+            </a:pPr>
+            <a:r>
+              <a:rPr lang="en-US" sz="1400" dirty="0">
+                <a:solidFill>
+                  <a:schemeClr val="tx2"/>
+                </a:solidFill>
+              </a:rPr>
+              <a:t>decision latency p99, dev machine</a:t>
+            </a:r>
+            <a:endParaRPr lang="en-US" sz="1400" dirty="0"/>
+          </a:p>
+        </p:txBody>
+      </p:sp>
+      <p:sp>
+        <p:nvSpPr>
+          <p:cNvPr id="12" name="Stat card 21"/>
+          <p:cNvSpPr/>
+          <p:nvPr/>
+        </p:nvSpPr>
+        <p:spPr>
+          <a:xfrm>
+            <a:off x="6355080" y="1188720"/>
+            <a:ext cx="2331720" cy="1508760"/>
+          </a:xfrm>
+          <a:prstGeom prst="roundRect">
+            <a:avLst>
+              <a:gd name="adj" fmla="val 4848"/>
+            </a:avLst>
+          </a:prstGeom>
+          <a:solidFill>
+            <a:schemeClr val="bg2"/>
+          </a:solidFill>
+          <a:ln w="6350">
+            <a:solidFill>
+              <a:schemeClr val="bg2"/>
+            </a:solidFill>
+            <a:prstDash val="solid"/>
+          </a:ln>
+        </p:spPr>
+      </p:sp>
+      <p:sp>
+        <p:nvSpPr>
+          <p:cNvPr id="13" name="Stat 21"/>
+          <p:cNvSpPr txBox="1"/>
+          <p:nvPr/>
+        </p:nvSpPr>
+        <p:spPr>
+          <a:xfrm>
+            <a:off x="6492240" y="1325880"/>
+            <a:ext cx="2057400" cy="685800"/>
           </a:xfrm>
           <a:prstGeom prst="rect">
             <a:avLst/>
@@ -8025,28 +9259,14 @@
               <a:buNone/>
             </a:pPr>
             <a:r>
-              <a:rPr lang="en-US" sz="1500" b="1" dirty="0">
-                <a:solidFill>
-                  <a:schemeClr val="tx1"/>
-                </a:solidFill>
-              </a:rPr>
-              <a:t>Robustness, cybersecurity</a:t>
-            </a:r>
-            <a:endParaRPr lang="en-US" sz="1500" dirty="0"/>
-          </a:p>
-          <a:p>
-            <a:pPr indent="0" marL="0">
-              <a:buNone/>
-            </a:pPr>
-            <a:r>
-              <a:rPr lang="en-US" sz="1300" dirty="0">
-                <a:solidFill>
-                  <a:schemeClr val="tx2"/>
-                </a:solidFill>
-              </a:rPr>
-              <a:t>HSM key, mTLS, anti-replay, fail-closed, signed rule bundle</a:t>
-            </a:r>
-            <a:endParaRPr lang="en-US" sz="1500" dirty="0"/>
+              <a:rPr lang="en-US" sz="4000" b="1" dirty="0">
+                <a:solidFill>
+                  <a:schemeClr val="accent1"/>
+                </a:solidFill>
+              </a:rPr>
+              <a:t>21</a:t>
+            </a:r>
+            <a:endParaRPr lang="en-US" sz="4000" dirty="0"/>
           </a:p>
         </p:txBody>
       </p:sp>
@@ -8058,31 +9278,31 @@
         </p:nvSpPr>
         <p:spPr>
           <a:xfrm>
-            <a:off x="7132320" y="3063240"/>
-            <a:ext cx="1371600" cy="777240"/>
-          </a:xfrm>
-          <a:prstGeom prst="rect">
-            <a:avLst/>
-          </a:prstGeom>
-          <a:noFill/>
-          <a:ln/>
-        </p:spPr>
-        <p:txBody>
-          <a:bodyPr wrap="square" lIns="0" tIns="0" rIns="0" bIns="0" rtlCol="0" anchor="ctr"/>
-          <a:lstStyle/>
-          <a:p>
-            <a:pPr algn="r" indent="0" marL="0">
-              <a:buNone/>
-            </a:pPr>
-            <a:r>
-              <a:rPr lang="en-US" sz="1500" b="1" dirty="0">
-                <a:solidFill>
-                  <a:schemeClr val="accent2"/>
-                </a:solidFill>
-              </a:rPr>
-              <a:t>Covered</a:t>
-            </a:r>
-            <a:endParaRPr lang="en-US" sz="1500" dirty="0"/>
+            <a:off x="6492240" y="2011680"/>
+            <a:ext cx="2057400" cy="640080"/>
+          </a:xfrm>
+          <a:prstGeom prst="rect">
+            <a:avLst/>
+          </a:prstGeom>
+          <a:noFill/>
+          <a:ln/>
+        </p:spPr>
+        <p:txBody>
+          <a:bodyPr wrap="square" lIns="0" tIns="0" rIns="0" bIns="0" rtlCol="0" anchor="t"/>
+          <a:lstStyle/>
+          <a:p>
+            <a:pPr indent="0" marL="0">
+              <a:buNone/>
+            </a:pPr>
+            <a:r>
+              <a:rPr lang="en-US" sz="1400" dirty="0">
+                <a:solidFill>
+                  <a:schemeClr val="tx2"/>
+                </a:solidFill>
+              </a:rPr>
+              <a:t>compliance mappings, read control by control</a:t>
+            </a:r>
+            <a:endParaRPr lang="en-US" sz="1400" dirty="0"/>
           </a:p>
         </p:txBody>
       </p:sp>
@@ -8094,8 +9314,8 @@
         </p:nvSpPr>
         <p:spPr>
           <a:xfrm>
-            <a:off x="457200" y="4023360"/>
-            <a:ext cx="8229600" cy="685800"/>
+            <a:off x="457200" y="2834640"/>
+            <a:ext cx="8229600" cy="1371600"/>
           </a:xfrm>
           <a:prstGeom prst="rect">
             <a:avLst/>
@@ -8107,18 +9327,94 @@
           <a:bodyPr wrap="square" lIns="0" tIns="0" rIns="0" bIns="0" rtlCol="0" anchor="t"/>
           <a:lstStyle/>
           <a:p>
+            <a:pPr marL="342900" indent="-342900">
+              <a:spcAft>
+                <a:spcPts val="600"/>
+              </a:spcAft>
+              <a:buSzPct val="100000"/>
+              <a:buChar char="•"/>
+            </a:pPr>
+            <a:r>
+              <a:rPr lang="en-US" sz="1400" dirty="0">
+                <a:solidFill>
+                  <a:schemeClr val="tx1"/>
+                </a:solidFill>
+              </a:rPr>
+              <a:t>Selftest runs on every code change (CI); fixes are mutation-tested.</a:t>
+            </a:r>
+            <a:endParaRPr lang="en-US" sz="1400" dirty="0"/>
+          </a:p>
+          <a:p>
+            <a:pPr marL="342900" indent="-342900">
+              <a:spcAft>
+                <a:spcPts val="600"/>
+              </a:spcAft>
+              <a:buSzPct val="100000"/>
+              <a:buChar char="•"/>
+            </a:pPr>
+            <a:r>
+              <a:rPr lang="en-US" sz="1400" dirty="0">
+                <a:solidFill>
+                  <a:schemeClr val="tx1"/>
+                </a:solidFill>
+              </a:rPr>
+              <a:t>Red team 1 Oct 2026: 5 passes, 25 files, static analysis. The high-severity finding is fixed and covered.</a:t>
+            </a:r>
+            <a:endParaRPr lang="en-US" sz="1400" dirty="0"/>
+          </a:p>
+          <a:p>
+            <a:pPr marL="342900" indent="-342900">
+              <a:spcAft>
+                <a:spcPts val="600"/>
+              </a:spcAft>
+              <a:buSzPct val="100000"/>
+              <a:buChar char="•"/>
+            </a:pPr>
+            <a:r>
+              <a:rPr lang="en-US" sz="1400" dirty="0">
+                <a:solidFill>
+                  <a:schemeClr val="tx1"/>
+                </a:solidFill>
+              </a:rPr>
+              <a:t>Latency measured on a 4-CPU development VM (2 Oct 2026): not a production result.</a:t>
+            </a:r>
+            <a:endParaRPr lang="en-US" sz="1400" dirty="0"/>
+          </a:p>
+        </p:txBody>
+      </p:sp>
+      <p:sp>
+        <p:nvSpPr>
+          <p:cNvPr id="16" name="Text 14"/>
+          <p:cNvSpPr txBox="1"/>
+          <p:nvPr/>
+        </p:nvSpPr>
+        <p:spPr>
+          <a:xfrm>
+            <a:off x="457200" y="4343400"/>
+            <a:ext cx="7680960" cy="274320"/>
+          </a:xfrm>
+          <a:prstGeom prst="rect">
+            <a:avLst/>
+          </a:prstGeom>
+          <a:noFill/>
+          <a:ln/>
+        </p:spPr>
+        <p:txBody>
+          <a:bodyPr wrap="square" lIns="0" tIns="0" rIns="0" bIns="0" rtlCol="0" anchor="ctr"/>
+          <a:lstStyle/>
+          <a:p>
             <a:pPr indent="0" marL="0">
               <a:buNone/>
             </a:pPr>
             <a:r>
-              <a:rPr lang="en-US" sz="1200" dirty="0">
-                <a:solidFill>
-                  <a:schemeClr val="tx2"/>
-                </a:solidFill>
-              </a:rPr>
-              <a:t>Art. 9, 10, 11, 13, 27, 43 (risk management, data, documentation, transparency, impact and conformity assessment) are organizational: out of scope, but TBP supplies records and stable reason codes to cite. “Covered” is not an attestation of compliance.</a:t>
-            </a:r>
-            <a:endParaRPr lang="en-US" sz="1200" dirty="0"/>
+              <a:rPr lang="en-US" sz="1100" dirty="0">
+                <a:solidFill>
+                  <a:schemeClr val="accent4"/>
+                </a:solidFill>
+              </a:rPr>
+              <a:t>Source: github.com/philippeabraxas-jpg/TBP-NETWORK (tests/, docs/audits/, tbp-compliance/)</a:t>
+            </a:r>
+            <a:endParaRPr lang="en-US" sz="1100" dirty="0"/>
           </a:p>
         </p:txBody>
       </p:sp>
@@ -8224,7 +9520,7 @@
                   <a:schemeClr val="tx1"/>
                 </a:solidFill>
               </a:rPr>
-              <a:t>One code base. The scale is a setting</a:t>
+              <a:t>EU AI Act: a mechanism, not a procedure</a:t>
             </a:r>
             <a:endParaRPr lang="en-US" sz="3000" dirty="0"/>
           </a:p>
@@ -8232,18 +9528,18 @@
       </p:sp>
       <p:sp>
         <p:nvSpPr>
-          <p:cNvPr id="3" name="Scale Scale 1"/>
+          <p:cNvPr id="3" name="Row Art. 12"/>
           <p:cNvSpPr/>
           <p:nvPr/>
         </p:nvSpPr>
         <p:spPr>
           <a:xfrm>
             <a:off x="457200" y="1234440"/>
-            <a:ext cx="1920240" cy="2103120"/>
+            <a:ext cx="8229600" cy="777240"/>
           </a:xfrm>
           <a:prstGeom prst="roundRect">
             <a:avLst>
-              <a:gd name="adj" fmla="val 3810"/>
+              <a:gd name="adj" fmla="val 9412"/>
             </a:avLst>
           </a:prstGeom>
           <a:solidFill>
@@ -8265,8 +9561,8 @@
         </p:nvSpPr>
         <p:spPr>
           <a:xfrm>
-            <a:off x="594360" y="1371600"/>
-            <a:ext cx="1645920" cy="365760"/>
+            <a:off x="640080" y="1234440"/>
+            <a:ext cx="1005840" cy="777240"/>
           </a:xfrm>
           <a:prstGeom prst="rect">
             <a:avLst/>
@@ -8282,14 +9578,14 @@
               <a:buNone/>
             </a:pPr>
             <a:r>
-              <a:rPr lang="en-US" sz="1800" b="1" dirty="0">
-                <a:solidFill>
-                  <a:schemeClr val="accent4"/>
-                </a:solidFill>
-              </a:rPr>
-              <a:t>Scale 1</a:t>
-            </a:r>
-            <a:endParaRPr lang="en-US" sz="1800" dirty="0"/>
+              <a:rPr lang="en-US" sz="2000" b="1" dirty="0">
+                <a:solidFill>
+                  <a:schemeClr val="accent1"/>
+                </a:solidFill>
+              </a:rPr>
+              <a:t>Art. 12</a:t>
+            </a:r>
+            <a:endParaRPr lang="en-US" sz="2000" dirty="0"/>
           </a:p>
         </p:txBody>
       </p:sp>
@@ -8301,31 +9597,45 @@
         </p:nvSpPr>
         <p:spPr>
           <a:xfrm>
-            <a:off x="594360" y="1783080"/>
-            <a:ext cx="1645920" cy="1005840"/>
-          </a:xfrm>
-          <a:prstGeom prst="rect">
-            <a:avLst/>
-          </a:prstGeom>
-          <a:noFill/>
-          <a:ln/>
-        </p:spPr>
-        <p:txBody>
-          <a:bodyPr wrap="square" lIns="0" tIns="0" rIns="0" bIns="0" rtlCol="0" anchor="t"/>
+            <a:off x="1737360" y="1234440"/>
+            <a:ext cx="5120640" cy="777240"/>
+          </a:xfrm>
+          <a:prstGeom prst="rect">
+            <a:avLst/>
+          </a:prstGeom>
+          <a:noFill/>
+          <a:ln/>
+        </p:spPr>
+        <p:txBody>
+          <a:bodyPr wrap="square" lIns="0" tIns="0" rIns="0" bIns="0" rtlCol="0" anchor="ctr"/>
           <a:lstStyle/>
           <a:p>
             <a:pPr indent="0" marL="0">
               <a:buNone/>
             </a:pPr>
             <a:r>
-              <a:rPr lang="en-US" sz="1400" dirty="0">
+              <a:rPr lang="en-US" sz="1500" b="1" dirty="0">
                 <a:solidFill>
                   <a:schemeClr val="tx1"/>
                 </a:solidFill>
               </a:rPr>
-              <a:t>One machine, one administrator</a:t>
-            </a:r>
-            <a:endParaRPr lang="en-US" sz="1400" dirty="0"/>
+              <a:t>Record-keeping</a:t>
+            </a:r>
+            <a:endParaRPr lang="en-US" sz="1500" dirty="0"/>
+          </a:p>
+          <a:p>
+            <a:pPr indent="0" marL="0">
+              <a:buNone/>
+            </a:pPr>
+            <a:r>
+              <a:rPr lang="en-US" sz="1300" dirty="0">
+                <a:solidFill>
+                  <a:schemeClr val="tx2"/>
+                </a:solidFill>
+              </a:rPr>
+              <a:t>Merkle chain, hash-only records, hardware signature</a:t>
+            </a:r>
+            <a:endParaRPr lang="en-US" sz="1500" dirty="0"/>
           </a:p>
         </p:txBody>
       </p:sp>
@@ -8337,8 +9647,8 @@
         </p:nvSpPr>
         <p:spPr>
           <a:xfrm>
-            <a:off x="594360" y="2834640"/>
-            <a:ext cx="1645920" cy="365760"/>
+            <a:off x="7132320" y="1234440"/>
+            <a:ext cx="1371600" cy="777240"/>
           </a:xfrm>
           <a:prstGeom prst="rect">
             <a:avLst/>
@@ -8350,35 +9660,35 @@
           <a:bodyPr wrap="square" lIns="0" tIns="0" rIns="0" bIns="0" rtlCol="0" anchor="ctr"/>
           <a:lstStyle/>
           <a:p>
-            <a:pPr indent="0" marL="0">
-              <a:buNone/>
-            </a:pPr>
-            <a:r>
-              <a:rPr lang="en-US" sz="1300" b="1" dirty="0">
-                <a:solidFill>
-                  <a:schemeClr val="tx2"/>
-                </a:solidFill>
-              </a:rPr>
-              <a:t>Quorum: k = 1</a:t>
-            </a:r>
-            <a:endParaRPr lang="en-US" sz="1300" dirty="0"/>
-          </a:p>
-        </p:txBody>
-      </p:sp>
-      <p:sp>
-        <p:nvSpPr>
-          <p:cNvPr id="7" name="Scale Scale 2"/>
+            <a:pPr algn="r" indent="0" marL="0">
+              <a:buNone/>
+            </a:pPr>
+            <a:r>
+              <a:rPr lang="en-US" sz="1500" b="1" dirty="0">
+                <a:solidFill>
+                  <a:schemeClr val="accent2"/>
+                </a:solidFill>
+              </a:rPr>
+              <a:t>Covered</a:t>
+            </a:r>
+            <a:endParaRPr lang="en-US" sz="1500" dirty="0"/>
+          </a:p>
+        </p:txBody>
+      </p:sp>
+      <p:sp>
+        <p:nvSpPr>
+          <p:cNvPr id="7" name="Row Art. 14"/>
           <p:cNvSpPr/>
           <p:nvPr/>
         </p:nvSpPr>
         <p:spPr>
           <a:xfrm>
-            <a:off x="2542032" y="1234440"/>
-            <a:ext cx="1920240" cy="2103120"/>
+            <a:off x="457200" y="2148840"/>
+            <a:ext cx="8229600" cy="777240"/>
           </a:xfrm>
           <a:prstGeom prst="roundRect">
             <a:avLst>
-              <a:gd name="adj" fmla="val 3810"/>
+              <a:gd name="adj" fmla="val 9412"/>
             </a:avLst>
           </a:prstGeom>
           <a:solidFill>
@@ -8400,8 +9710,8 @@
         </p:nvSpPr>
         <p:spPr>
           <a:xfrm>
-            <a:off x="2679192" y="1371600"/>
-            <a:ext cx="1645920" cy="365760"/>
+            <a:off x="640080" y="2148840"/>
+            <a:ext cx="1005840" cy="777240"/>
           </a:xfrm>
           <a:prstGeom prst="rect">
             <a:avLst/>
@@ -8417,14 +9727,14 @@
               <a:buNone/>
             </a:pPr>
             <a:r>
-              <a:rPr lang="en-US" sz="1800" b="1" dirty="0">
+              <a:rPr lang="en-US" sz="2000" b="1" dirty="0">
                 <a:solidFill>
                   <a:schemeClr val="accent1"/>
                 </a:solidFill>
               </a:rPr>
-              <a:t>Scale 2</a:t>
-            </a:r>
-            <a:endParaRPr lang="en-US" sz="1800" dirty="0"/>
+              <a:t>Art. 14</a:t>
+            </a:r>
+            <a:endParaRPr lang="en-US" sz="2000" dirty="0"/>
           </a:p>
         </p:txBody>
       </p:sp>
@@ -8436,31 +9746,45 @@
         </p:nvSpPr>
         <p:spPr>
           <a:xfrm>
-            <a:off x="2679192" y="1783080"/>
-            <a:ext cx="1645920" cy="1005840"/>
-          </a:xfrm>
-          <a:prstGeom prst="rect">
-            <a:avLst/>
-          </a:prstGeom>
-          <a:noFill/>
-          <a:ln/>
-        </p:spPr>
-        <p:txBody>
-          <a:bodyPr wrap="square" lIns="0" tIns="0" rIns="0" bIns="0" rtlCol="0" anchor="t"/>
+            <a:off x="1737360" y="2148840"/>
+            <a:ext cx="5120640" cy="777240"/>
+          </a:xfrm>
+          <a:prstGeom prst="rect">
+            <a:avLst/>
+          </a:prstGeom>
+          <a:noFill/>
+          <a:ln/>
+        </p:spPr>
+        <p:txBody>
+          <a:bodyPr wrap="square" lIns="0" tIns="0" rIns="0" bIns="0" rtlCol="0" anchor="ctr"/>
           <a:lstStyle/>
           <a:p>
             <a:pPr indent="0" marL="0">
               <a:buNone/>
             </a:pPr>
             <a:r>
-              <a:rPr lang="en-US" sz="1400" dirty="0">
+              <a:rPr lang="en-US" sz="1500" b="1" dirty="0">
                 <a:solidFill>
                   <a:schemeClr val="tx1"/>
                 </a:solidFill>
               </a:rPr>
-              <a:t>Small site behind one broker, 802.1X</a:t>
-            </a:r>
-            <a:endParaRPr lang="en-US" sz="1400" dirty="0"/>
+              <a:t>Human oversight</a:t>
+            </a:r>
+            <a:endParaRPr lang="en-US" sz="1500" dirty="0"/>
+          </a:p>
+          <a:p>
+            <a:pPr indent="0" marL="0">
+              <a:buNone/>
+            </a:pPr>
+            <a:r>
+              <a:rPr lang="en-US" sz="1300" dirty="0">
+                <a:solidFill>
+                  <a:schemeClr val="tx2"/>
+                </a:solidFill>
+              </a:rPr>
+              <a:t>k-of-n co-signature before an irreversible action</a:t>
+            </a:r>
+            <a:endParaRPr lang="en-US" sz="1500" dirty="0"/>
           </a:p>
         </p:txBody>
       </p:sp>
@@ -8472,8 +9796,8 @@
         </p:nvSpPr>
         <p:spPr>
           <a:xfrm>
-            <a:off x="2679192" y="2834640"/>
-            <a:ext cx="1645920" cy="365760"/>
+            <a:off x="7132320" y="2148840"/>
+            <a:ext cx="1371600" cy="777240"/>
           </a:xfrm>
           <a:prstGeom prst="rect">
             <a:avLst/>
@@ -8485,35 +9809,35 @@
           <a:bodyPr wrap="square" lIns="0" tIns="0" rIns="0" bIns="0" rtlCol="0" anchor="ctr"/>
           <a:lstStyle/>
           <a:p>
-            <a:pPr indent="0" marL="0">
-              <a:buNone/>
-            </a:pPr>
-            <a:r>
-              <a:rPr lang="en-US" sz="1300" b="1" dirty="0">
-                <a:solidFill>
-                  <a:schemeClr val="tx2"/>
-                </a:solidFill>
-              </a:rPr>
-              <a:t>Quorum: k = 2 of 3</a:t>
-            </a:r>
-            <a:endParaRPr lang="en-US" sz="1300" dirty="0"/>
-          </a:p>
-        </p:txBody>
-      </p:sp>
-      <p:sp>
-        <p:nvSpPr>
-          <p:cNvPr id="11" name="Scale Scale 3"/>
+            <a:pPr algn="r" indent="0" marL="0">
+              <a:buNone/>
+            </a:pPr>
+            <a:r>
+              <a:rPr lang="en-US" sz="1500" b="1" dirty="0">
+                <a:solidFill>
+                  <a:schemeClr val="accent2"/>
+                </a:solidFill>
+              </a:rPr>
+              <a:t>Covered</a:t>
+            </a:r>
+            <a:endParaRPr lang="en-US" sz="1500" dirty="0"/>
+          </a:p>
+        </p:txBody>
+      </p:sp>
+      <p:sp>
+        <p:nvSpPr>
+          <p:cNvPr id="11" name="Row Art. 15"/>
           <p:cNvSpPr/>
           <p:nvPr/>
         </p:nvSpPr>
         <p:spPr>
           <a:xfrm>
-            <a:off x="4626864" y="1234440"/>
-            <a:ext cx="1920240" cy="2103120"/>
+            <a:off x="457200" y="3063240"/>
+            <a:ext cx="8229600" cy="777240"/>
           </a:xfrm>
           <a:prstGeom prst="roundRect">
             <a:avLst>
-              <a:gd name="adj" fmla="val 3810"/>
+              <a:gd name="adj" fmla="val 9412"/>
             </a:avLst>
           </a:prstGeom>
           <a:solidFill>
@@ -8535,8 +9859,8 @@
         </p:nvSpPr>
         <p:spPr>
           <a:xfrm>
-            <a:off x="4764024" y="1371600"/>
-            <a:ext cx="1645920" cy="365760"/>
+            <a:off x="640080" y="3063240"/>
+            <a:ext cx="1005840" cy="777240"/>
           </a:xfrm>
           <a:prstGeom prst="rect">
             <a:avLst/>
@@ -8552,14 +9876,14 @@
               <a:buNone/>
             </a:pPr>
             <a:r>
-              <a:rPr lang="en-US" sz="1800" b="1" dirty="0">
+              <a:rPr lang="en-US" sz="2000" b="1" dirty="0">
                 <a:solidFill>
                   <a:schemeClr val="accent1"/>
                 </a:solidFill>
               </a:rPr>
-              <a:t>Scale 3</a:t>
-            </a:r>
-            <a:endParaRPr lang="en-US" sz="1800" dirty="0"/>
+              <a:t>Art. 15</a:t>
+            </a:r>
+            <a:endParaRPr lang="en-US" sz="2000" dirty="0"/>
           </a:p>
         </p:txBody>
       </p:sp>
@@ -8571,31 +9895,45 @@
         </p:nvSpPr>
         <p:spPr>
           <a:xfrm>
-            <a:off x="4764024" y="1783080"/>
-            <a:ext cx="1645920" cy="1005840"/>
-          </a:xfrm>
-          <a:prstGeom prst="rect">
-            <a:avLst/>
-          </a:prstGeom>
-          <a:noFill/>
-          <a:ln/>
-        </p:spPr>
-        <p:txBody>
-          <a:bodyPr wrap="square" lIns="0" tIns="0" rIns="0" bIns="0" rtlCol="0" anchor="t"/>
+            <a:off x="1737360" y="3063240"/>
+            <a:ext cx="5120640" cy="777240"/>
+          </a:xfrm>
+          <a:prstGeom prst="rect">
+            <a:avLst/>
+          </a:prstGeom>
+          <a:noFill/>
+          <a:ln/>
+        </p:spPr>
+        <p:txBody>
+          <a:bodyPr wrap="square" lIns="0" tIns="0" rIns="0" bIns="0" rtlCol="0" anchor="ctr"/>
           <a:lstStyle/>
           <a:p>
             <a:pPr indent="0" marL="0">
               <a:buNone/>
             </a:pPr>
             <a:r>
-              <a:rPr lang="en-US" sz="1400" dirty="0">
+              <a:rPr lang="en-US" sz="1500" b="1" dirty="0">
                 <a:solidFill>
                   <a:schemeClr val="tx1"/>
                 </a:solidFill>
               </a:rPr>
-              <a:t>Several cells, epoch lease, independent supervisor</a:t>
-            </a:r>
-            <a:endParaRPr lang="en-US" sz="1400" dirty="0"/>
+              <a:t>Robustness, cybersecurity</a:t>
+            </a:r>
+            <a:endParaRPr lang="en-US" sz="1500" dirty="0"/>
+          </a:p>
+          <a:p>
+            <a:pPr indent="0" marL="0">
+              <a:buNone/>
+            </a:pPr>
+            <a:r>
+              <a:rPr lang="en-US" sz="1300" dirty="0">
+                <a:solidFill>
+                  <a:schemeClr val="tx2"/>
+                </a:solidFill>
+              </a:rPr>
+              <a:t>HSM key, mTLS, anti-replay, fail-closed, signed rule bundle</a:t>
+            </a:r>
+            <a:endParaRPr lang="en-US" sz="1500" dirty="0"/>
           </a:p>
         </p:txBody>
       </p:sp>
@@ -8607,8 +9945,8 @@
         </p:nvSpPr>
         <p:spPr>
           <a:xfrm>
-            <a:off x="4764024" y="2834640"/>
-            <a:ext cx="1645920" cy="365760"/>
+            <a:off x="7132320" y="3063240"/>
+            <a:ext cx="1371600" cy="777240"/>
           </a:xfrm>
           <a:prstGeom prst="rect">
             <a:avLst/>
@@ -8620,189 +9958,54 @@
           <a:bodyPr wrap="square" lIns="0" tIns="0" rIns="0" bIns="0" rtlCol="0" anchor="ctr"/>
           <a:lstStyle/>
           <a:p>
+            <a:pPr algn="r" indent="0" marL="0">
+              <a:buNone/>
+            </a:pPr>
+            <a:r>
+              <a:rPr lang="en-US" sz="1500" b="1" dirty="0">
+                <a:solidFill>
+                  <a:schemeClr val="accent2"/>
+                </a:solidFill>
+              </a:rPr>
+              <a:t>Covered</a:t>
+            </a:r>
+            <a:endParaRPr lang="en-US" sz="1500" dirty="0"/>
+          </a:p>
+        </p:txBody>
+      </p:sp>
+      <p:sp>
+        <p:nvSpPr>
+          <p:cNvPr id="15" name="Text 13"/>
+          <p:cNvSpPr txBox="1"/>
+          <p:nvPr/>
+        </p:nvSpPr>
+        <p:spPr>
+          <a:xfrm>
+            <a:off x="457200" y="4023360"/>
+            <a:ext cx="8229600" cy="685800"/>
+          </a:xfrm>
+          <a:prstGeom prst="rect">
+            <a:avLst/>
+          </a:prstGeom>
+          <a:noFill/>
+          <a:ln/>
+        </p:spPr>
+        <p:txBody>
+          <a:bodyPr wrap="square" lIns="0" tIns="0" rIns="0" bIns="0" rtlCol="0" anchor="t"/>
+          <a:lstStyle/>
+          <a:p>
             <a:pPr indent="0" marL="0">
               <a:buNone/>
             </a:pPr>
             <a:r>
-              <a:rPr lang="en-US" sz="1300" b="1" dirty="0">
+              <a:rPr lang="en-US" sz="1200" dirty="0">
                 <a:solidFill>
                   <a:schemeClr val="tx2"/>
                 </a:solidFill>
               </a:rPr>
-              <a:t>Quorum: k of n, HSM</a:t>
-            </a:r>
-            <a:endParaRPr lang="en-US" sz="1300" dirty="0"/>
-          </a:p>
-        </p:txBody>
-      </p:sp>
-      <p:sp>
-        <p:nvSpPr>
-          <p:cNvPr id="15" name="Scale Full scale"/>
-          <p:cNvSpPr/>
-          <p:nvPr/>
-        </p:nvSpPr>
-        <p:spPr>
-          <a:xfrm>
-            <a:off x="6711696" y="1234440"/>
-            <a:ext cx="1920240" cy="2103120"/>
-          </a:xfrm>
-          <a:prstGeom prst="roundRect">
-            <a:avLst>
-              <a:gd name="adj" fmla="val 3810"/>
-            </a:avLst>
-          </a:prstGeom>
-          <a:solidFill>
-            <a:schemeClr val="bg2"/>
-          </a:solidFill>
-          <a:ln w="6350">
-            <a:solidFill>
-              <a:schemeClr val="bg2"/>
-            </a:solidFill>
-            <a:prstDash val="solid"/>
-          </a:ln>
-        </p:spPr>
-      </p:sp>
-      <p:sp>
-        <p:nvSpPr>
-          <p:cNvPr id="16" name="Text 14"/>
-          <p:cNvSpPr txBox="1"/>
-          <p:nvPr/>
-        </p:nvSpPr>
-        <p:spPr>
-          <a:xfrm>
-            <a:off x="6848856" y="1371600"/>
-            <a:ext cx="1645920" cy="365760"/>
-          </a:xfrm>
-          <a:prstGeom prst="rect">
-            <a:avLst/>
-          </a:prstGeom>
-          <a:noFill/>
-          <a:ln/>
-        </p:spPr>
-        <p:txBody>
-          <a:bodyPr wrap="square" lIns="0" tIns="0" rIns="0" bIns="0" rtlCol="0" anchor="ctr"/>
-          <a:lstStyle/>
-          <a:p>
-            <a:pPr indent="0" marL="0">
-              <a:buNone/>
-            </a:pPr>
-            <a:r>
-              <a:rPr lang="en-US" sz="1800" b="1" dirty="0">
-                <a:solidFill>
-                  <a:schemeClr val="accent4"/>
-                </a:solidFill>
-              </a:rPr>
-              <a:t>Full scale</a:t>
-            </a:r>
-            <a:endParaRPr lang="en-US" sz="1800" dirty="0"/>
-          </a:p>
-        </p:txBody>
-      </p:sp>
-      <p:sp>
-        <p:nvSpPr>
-          <p:cNvPr id="17" name="Text 15"/>
-          <p:cNvSpPr txBox="1"/>
-          <p:nvPr/>
-        </p:nvSpPr>
-        <p:spPr>
-          <a:xfrm>
-            <a:off x="6848856" y="1783080"/>
-            <a:ext cx="1645920" cy="1005840"/>
-          </a:xfrm>
-          <a:prstGeom prst="rect">
-            <a:avLst/>
-          </a:prstGeom>
-          <a:noFill/>
-          <a:ln/>
-        </p:spPr>
-        <p:txBody>
-          <a:bodyPr wrap="square" lIns="0" tIns="0" rIns="0" bIns="0" rtlCol="0" anchor="t"/>
-          <a:lstStyle/>
-          <a:p>
-            <a:pPr indent="0" marL="0">
-              <a:buNone/>
-            </a:pPr>
-            <a:r>
-              <a:rPr lang="en-US" sz="1400" dirty="0">
-                <a:solidFill>
-                  <a:schemeClr val="tx1"/>
-                </a:solidFill>
-              </a:rPr>
-              <a:t>Several entities proving policy to each other</a:t>
-            </a:r>
-            <a:endParaRPr lang="en-US" sz="1400" dirty="0"/>
-          </a:p>
-        </p:txBody>
-      </p:sp>
-      <p:sp>
-        <p:nvSpPr>
-          <p:cNvPr id="18" name="Text 16"/>
-          <p:cNvSpPr txBox="1"/>
-          <p:nvPr/>
-        </p:nvSpPr>
-        <p:spPr>
-          <a:xfrm>
-            <a:off x="6848856" y="2834640"/>
-            <a:ext cx="1645920" cy="365760"/>
-          </a:xfrm>
-          <a:prstGeom prst="rect">
-            <a:avLst/>
-          </a:prstGeom>
-          <a:noFill/>
-          <a:ln/>
-        </p:spPr>
-        <p:txBody>
-          <a:bodyPr wrap="square" lIns="0" tIns="0" rIns="0" bIns="0" rtlCol="0" anchor="ctr"/>
-          <a:lstStyle/>
-          <a:p>
-            <a:pPr indent="0" marL="0">
-              <a:buNone/>
-            </a:pPr>
-            <a:r>
-              <a:rPr lang="en-US" sz="1300" b="1" dirty="0">
-                <a:solidFill>
-                  <a:schemeClr val="tx2"/>
-                </a:solidFill>
-              </a:rPr>
-              <a:t>Quorum: Not started</a:t>
-            </a:r>
-            <a:endParaRPr lang="en-US" sz="1300" dirty="0"/>
-          </a:p>
-        </p:txBody>
-      </p:sp>
-      <p:sp>
-        <p:nvSpPr>
-          <p:cNvPr id="19" name="Text 17"/>
-          <p:cNvSpPr txBox="1"/>
-          <p:nvPr/>
-        </p:nvSpPr>
-        <p:spPr>
-          <a:xfrm>
-            <a:off x="457200" y="3566160"/>
-            <a:ext cx="8229600" cy="1005840"/>
-          </a:xfrm>
-          <a:prstGeom prst="rect">
-            <a:avLst/>
-          </a:prstGeom>
-          <a:noFill/>
-          <a:ln/>
-        </p:spPr>
-        <p:txBody>
-          <a:bodyPr wrap="square" lIns="0" tIns="0" rIns="0" bIns="0" rtlCol="0" anchor="t"/>
-          <a:lstStyle/>
-          <a:p>
-            <a:pPr indent="0" marL="0">
-              <a:buNone/>
-            </a:pPr>
-            <a:r>
-              <a:rPr lang="en-US" sz="1600" dirty="0">
-                <a:solidFill>
-                  <a:schemeClr val="tx1"/>
-                </a:solidFill>
-              </a:rPr>
-              <a:t>Sensitive organizations start where their risk is, and raise the level without changing product. Installation guides for scales 1 and 2 are in the repository, with a verifiable success criterion per step.</a:t>
-            </a:r>
-            <a:endParaRPr lang="en-US" sz="1600" dirty="0"/>
+              <a:t>Art. 9, 10, 11, 13, 27, 43 (risk management, data, documentation, transparency, impact and conformity assessment) are organizational: out of scope, but TBP supplies records and stable reason codes to cite. “Covered” is not an attestation of compliance.</a:t>
+            </a:r>
+            <a:endParaRPr lang="en-US" sz="1200" dirty="0"/>
           </a:p>
         </p:txBody>
       </p:sp>

</xml_diff>